<commit_message>
Update 초성 퀴즈 assets and add ZIP slides
Co-Authored-By: Claude Opus 4.6 (1M context) <noreply@anthropic.com>
</commit_message>
<xml_diff>
--- a/public/downloads/games/chosung-quiz/rules.pptx
+++ b/public/downloads/games/chosung-quiz/rules.pptx
@@ -95,16 +95,12 @@
   <p:notesSz cx="6858000" cy="9144000"/>
   <p:embeddedFontLst>
     <p:embeddedFont>
-      <p:font typeface="Jua" charset="1" panose="00000000000000000000"/>
+      <p:font typeface="무궁화 고딕" charset="1" panose="02020603020101020101"/>
       <p:regular r:id="rId91"/>
     </p:embeddedFont>
     <p:embeddedFont>
-      <p:font typeface="TDTD갬성명조" charset="1" panose="02000503000000000000"/>
+      <p:font typeface="무궁화 고딕 Bold" charset="1" panose="02020603020101020101"/>
       <p:regular r:id="rId92"/>
-    </p:embeddedFont>
-    <p:embeddedFont>
-      <p:font typeface="TDTD가온" charset="1" panose="02000503000000000000"/>
-      <p:regular r:id="rId93"/>
     </p:embeddedFont>
   </p:embeddedFontLst>
   <p:defaultTextStyle>
@@ -3222,8 +3218,8 @@
         </p:nvSpPr>
         <p:spPr>
           <a:xfrm rot="0">
-            <a:off x="1028700" y="3892867"/>
-            <a:ext cx="15555091" cy="2200275"/>
+            <a:off x="1028700" y="4178617"/>
+            <a:ext cx="15555091" cy="1914525"/>
           </a:xfrm>
           <a:prstGeom prst="rect">
             <a:avLst/>
@@ -3245,10 +3241,10 @@
                 <a:solidFill>
                   <a:srgbClr val="FFFAEF"/>
                 </a:solidFill>
-                <a:latin typeface="Jua"/>
-                <a:ea typeface="Jua"/>
-                <a:cs typeface="Jua"/>
-                <a:sym typeface="Jua"/>
+                <a:latin typeface="무궁화 고딕"/>
+                <a:ea typeface="무궁화 고딕"/>
+                <a:cs typeface="무궁화 고딕"/>
+                <a:sym typeface="무궁화 고딕"/>
               </a:rPr>
               <a:t>초성 퀴즈</a:t>
             </a:r>
@@ -3263,8 +3259,8 @@
         </p:nvSpPr>
         <p:spPr>
           <a:xfrm rot="0">
-            <a:off x="15264803" y="9812655"/>
-            <a:ext cx="2637975" cy="474345"/>
+            <a:off x="14542909" y="9822180"/>
+            <a:ext cx="3359870" cy="464820"/>
           </a:xfrm>
           <a:prstGeom prst="rect">
             <a:avLst/>
@@ -3289,10 +3285,10 @@
                 <a:solidFill>
                   <a:srgbClr val="FFFFFF"/>
                 </a:solidFill>
-                <a:latin typeface="TDTD갬성명조"/>
-                <a:ea typeface="TDTD갬성명조"/>
-                <a:cs typeface="TDTD갬성명조"/>
-                <a:sym typeface="TDTD갬성명조"/>
+                <a:latin typeface="무궁화 고딕"/>
+                <a:ea typeface="무궁화 고딕"/>
+                <a:cs typeface="무궁화 고딕"/>
+                <a:sym typeface="무궁화 고딕"/>
               </a:rPr>
               <a:t>ⓒ 2026. Sunday Play</a:t>
             </a:r>
@@ -3389,8 +3385,8 @@
         </p:nvSpPr>
         <p:spPr>
           <a:xfrm rot="0">
-            <a:off x="461635" y="3152775"/>
-            <a:ext cx="17364730" cy="3514725"/>
+            <a:off x="461635" y="3609975"/>
+            <a:ext cx="17364730" cy="3057525"/>
           </a:xfrm>
           <a:prstGeom prst="rect">
             <a:avLst/>
@@ -3412,10 +3408,10 @@
                 <a:solidFill>
                   <a:srgbClr val="000000"/>
                 </a:solidFill>
-                <a:latin typeface="Jua"/>
-                <a:ea typeface="Jua"/>
-                <a:cs typeface="Jua"/>
-                <a:sym typeface="Jua"/>
+                <a:latin typeface="무궁화 고딕"/>
+                <a:ea typeface="무궁화 고딕"/>
+                <a:cs typeface="무궁화 고딕"/>
+                <a:sym typeface="무궁화 고딕"/>
               </a:rPr>
               <a:t>ㄱㄱㅁ</a:t>
             </a:r>
@@ -3430,8 +3426,8 @@
         </p:nvSpPr>
         <p:spPr>
           <a:xfrm rot="0">
-            <a:off x="461635" y="6533441"/>
-            <a:ext cx="17364730" cy="1952625"/>
+            <a:off x="461635" y="6800141"/>
+            <a:ext cx="17364730" cy="1685925"/>
           </a:xfrm>
           <a:prstGeom prst="rect">
             <a:avLst/>
@@ -3453,10 +3449,10 @@
                 <a:solidFill>
                   <a:srgbClr val="000000"/>
                 </a:solidFill>
-                <a:latin typeface="Jua"/>
-                <a:ea typeface="Jua"/>
-                <a:cs typeface="Jua"/>
-                <a:sym typeface="Jua"/>
+                <a:latin typeface="무궁화 고딕"/>
+                <a:ea typeface="무궁화 고딕"/>
+                <a:cs typeface="무궁화 고딕"/>
+                <a:sym typeface="무궁화 고딕"/>
               </a:rPr>
               <a:t>Hint : 노란색</a:t>
             </a:r>
@@ -3553,8 +3549,8 @@
         </p:nvSpPr>
         <p:spPr>
           <a:xfrm rot="0">
-            <a:off x="461635" y="3152775"/>
-            <a:ext cx="17364730" cy="3514725"/>
+            <a:off x="461635" y="3609975"/>
+            <a:ext cx="17364730" cy="3057525"/>
           </a:xfrm>
           <a:prstGeom prst="rect">
             <a:avLst/>
@@ -3576,10 +3572,10 @@
                 <a:solidFill>
                   <a:srgbClr val="000000"/>
                 </a:solidFill>
-                <a:latin typeface="Jua"/>
-                <a:ea typeface="Jua"/>
-                <a:cs typeface="Jua"/>
-                <a:sym typeface="Jua"/>
+                <a:latin typeface="무궁화 고딕"/>
+                <a:ea typeface="무궁화 고딕"/>
+                <a:cs typeface="무궁화 고딕"/>
+                <a:sym typeface="무궁화 고딕"/>
               </a:rPr>
               <a:t>고구마</a:t>
             </a:r>
@@ -3676,8 +3672,8 @@
         </p:nvSpPr>
         <p:spPr>
           <a:xfrm rot="0">
-            <a:off x="461635" y="3152775"/>
-            <a:ext cx="17364730" cy="3514725"/>
+            <a:off x="461635" y="3609975"/>
+            <a:ext cx="17364730" cy="3057525"/>
           </a:xfrm>
           <a:prstGeom prst="rect">
             <a:avLst/>
@@ -3699,10 +3695,10 @@
                 <a:solidFill>
                   <a:srgbClr val="000000"/>
                 </a:solidFill>
-                <a:latin typeface="Jua"/>
-                <a:ea typeface="Jua"/>
-                <a:cs typeface="Jua"/>
-                <a:sym typeface="Jua"/>
+                <a:latin typeface="무궁화 고딕"/>
+                <a:ea typeface="무궁화 고딕"/>
+                <a:cs typeface="무궁화 고딕"/>
+                <a:sym typeface="무궁화 고딕"/>
               </a:rPr>
               <a:t>ㄸㅂㅇ</a:t>
             </a:r>
@@ -3799,8 +3795,8 @@
         </p:nvSpPr>
         <p:spPr>
           <a:xfrm rot="0">
-            <a:off x="461635" y="3152775"/>
-            <a:ext cx="17364730" cy="3514725"/>
+            <a:off x="461635" y="3609975"/>
+            <a:ext cx="17364730" cy="3057525"/>
           </a:xfrm>
           <a:prstGeom prst="rect">
             <a:avLst/>
@@ -3822,10 +3818,10 @@
                 <a:solidFill>
                   <a:srgbClr val="000000"/>
                 </a:solidFill>
-                <a:latin typeface="Jua"/>
-                <a:ea typeface="Jua"/>
-                <a:cs typeface="Jua"/>
-                <a:sym typeface="Jua"/>
+                <a:latin typeface="무궁화 고딕"/>
+                <a:ea typeface="무궁화 고딕"/>
+                <a:cs typeface="무궁화 고딕"/>
+                <a:sym typeface="무궁화 고딕"/>
               </a:rPr>
               <a:t>ㄸㅂㅇ</a:t>
             </a:r>
@@ -3840,8 +3836,8 @@
         </p:nvSpPr>
         <p:spPr>
           <a:xfrm rot="0">
-            <a:off x="461635" y="6533441"/>
-            <a:ext cx="17364730" cy="1952625"/>
+            <a:off x="461635" y="6800141"/>
+            <a:ext cx="17364730" cy="1685925"/>
           </a:xfrm>
           <a:prstGeom prst="rect">
             <a:avLst/>
@@ -3863,10 +3859,10 @@
                 <a:solidFill>
                   <a:srgbClr val="000000"/>
                 </a:solidFill>
-                <a:latin typeface="Jua"/>
-                <a:ea typeface="Jua"/>
-                <a:cs typeface="Jua"/>
-                <a:sym typeface="Jua"/>
+                <a:latin typeface="무궁화 고딕"/>
+                <a:ea typeface="무궁화 고딕"/>
+                <a:cs typeface="무궁화 고딕"/>
+                <a:sym typeface="무궁화 고딕"/>
               </a:rPr>
               <a:t>Hint : 매워요</a:t>
             </a:r>
@@ -3963,8 +3959,8 @@
         </p:nvSpPr>
         <p:spPr>
           <a:xfrm rot="0">
-            <a:off x="461635" y="3152775"/>
-            <a:ext cx="17364730" cy="3514725"/>
+            <a:off x="461635" y="3609975"/>
+            <a:ext cx="17364730" cy="3057525"/>
           </a:xfrm>
           <a:prstGeom prst="rect">
             <a:avLst/>
@@ -3986,10 +3982,10 @@
                 <a:solidFill>
                   <a:srgbClr val="000000"/>
                 </a:solidFill>
-                <a:latin typeface="Jua"/>
-                <a:ea typeface="Jua"/>
-                <a:cs typeface="Jua"/>
-                <a:sym typeface="Jua"/>
+                <a:latin typeface="무궁화 고딕"/>
+                <a:ea typeface="무궁화 고딕"/>
+                <a:cs typeface="무궁화 고딕"/>
+                <a:sym typeface="무궁화 고딕"/>
               </a:rPr>
               <a:t>떡볶이</a:t>
             </a:r>
@@ -4086,8 +4082,8 @@
         </p:nvSpPr>
         <p:spPr>
           <a:xfrm rot="0">
-            <a:off x="461635" y="3152775"/>
-            <a:ext cx="17364730" cy="3514725"/>
+            <a:off x="461635" y="3609975"/>
+            <a:ext cx="17364730" cy="3057525"/>
           </a:xfrm>
           <a:prstGeom prst="rect">
             <a:avLst/>
@@ -4109,10 +4105,10 @@
                 <a:solidFill>
                   <a:srgbClr val="000000"/>
                 </a:solidFill>
-                <a:latin typeface="Jua"/>
-                <a:ea typeface="Jua"/>
-                <a:cs typeface="Jua"/>
-                <a:sym typeface="Jua"/>
+                <a:latin typeface="무궁화 고딕"/>
+                <a:ea typeface="무궁화 고딕"/>
+                <a:cs typeface="무궁화 고딕"/>
+                <a:sym typeface="무궁화 고딕"/>
               </a:rPr>
               <a:t>ㄱㅊㅉㄱ</a:t>
             </a:r>
@@ -4209,8 +4205,8 @@
         </p:nvSpPr>
         <p:spPr>
           <a:xfrm rot="0">
-            <a:off x="461635" y="3152775"/>
-            <a:ext cx="17364730" cy="3514725"/>
+            <a:off x="461635" y="3609975"/>
+            <a:ext cx="17364730" cy="3057525"/>
           </a:xfrm>
           <a:prstGeom prst="rect">
             <a:avLst/>
@@ -4232,10 +4228,10 @@
                 <a:solidFill>
                   <a:srgbClr val="000000"/>
                 </a:solidFill>
-                <a:latin typeface="Jua"/>
-                <a:ea typeface="Jua"/>
-                <a:cs typeface="Jua"/>
-                <a:sym typeface="Jua"/>
+                <a:latin typeface="무궁화 고딕"/>
+                <a:ea typeface="무궁화 고딕"/>
+                <a:cs typeface="무궁화 고딕"/>
+                <a:sym typeface="무궁화 고딕"/>
               </a:rPr>
               <a:t>ㄱㅊㅉㄱ</a:t>
             </a:r>
@@ -4250,8 +4246,8 @@
         </p:nvSpPr>
         <p:spPr>
           <a:xfrm rot="0">
-            <a:off x="461635" y="6533441"/>
-            <a:ext cx="17364730" cy="1952625"/>
+            <a:off x="461635" y="6800141"/>
+            <a:ext cx="17364730" cy="1685925"/>
           </a:xfrm>
           <a:prstGeom prst="rect">
             <a:avLst/>
@@ -4273,10 +4269,10 @@
                 <a:solidFill>
                   <a:srgbClr val="000000"/>
                 </a:solidFill>
-                <a:latin typeface="Jua"/>
-                <a:ea typeface="Jua"/>
-                <a:cs typeface="Jua"/>
-                <a:sym typeface="Jua"/>
+                <a:latin typeface="무궁화 고딕"/>
+                <a:ea typeface="무궁화 고딕"/>
+                <a:cs typeface="무궁화 고딕"/>
+                <a:sym typeface="무궁화 고딕"/>
               </a:rPr>
               <a:t>Hint : 한식</a:t>
             </a:r>
@@ -4373,8 +4369,8 @@
         </p:nvSpPr>
         <p:spPr>
           <a:xfrm rot="0">
-            <a:off x="461635" y="3152775"/>
-            <a:ext cx="17364730" cy="3514725"/>
+            <a:off x="461635" y="3609975"/>
+            <a:ext cx="17364730" cy="3057525"/>
           </a:xfrm>
           <a:prstGeom prst="rect">
             <a:avLst/>
@@ -4396,10 +4392,10 @@
                 <a:solidFill>
                   <a:srgbClr val="000000"/>
                 </a:solidFill>
-                <a:latin typeface="Jua"/>
-                <a:ea typeface="Jua"/>
-                <a:cs typeface="Jua"/>
-                <a:sym typeface="Jua"/>
+                <a:latin typeface="무궁화 고딕"/>
+                <a:ea typeface="무궁화 고딕"/>
+                <a:cs typeface="무궁화 고딕"/>
+                <a:sym typeface="무궁화 고딕"/>
               </a:rPr>
               <a:t>김치찌개</a:t>
             </a:r>
@@ -4496,8 +4492,8 @@
         </p:nvSpPr>
         <p:spPr>
           <a:xfrm rot="0">
-            <a:off x="461635" y="3152775"/>
-            <a:ext cx="17364730" cy="3514725"/>
+            <a:off x="461635" y="3609975"/>
+            <a:ext cx="17364730" cy="3057525"/>
           </a:xfrm>
           <a:prstGeom prst="rect">
             <a:avLst/>
@@ -4519,10 +4515,10 @@
                 <a:solidFill>
                   <a:srgbClr val="000000"/>
                 </a:solidFill>
-                <a:latin typeface="Jua"/>
-                <a:ea typeface="Jua"/>
-                <a:cs typeface="Jua"/>
-                <a:sym typeface="Jua"/>
+                <a:latin typeface="무궁화 고딕"/>
+                <a:ea typeface="무궁화 고딕"/>
+                <a:cs typeface="무궁화 고딕"/>
+                <a:sym typeface="무궁화 고딕"/>
               </a:rPr>
               <a:t>ㅊㅋㅋㅇㅋ</a:t>
             </a:r>
@@ -4619,8 +4615,8 @@
         </p:nvSpPr>
         <p:spPr>
           <a:xfrm rot="0">
-            <a:off x="461635" y="3152775"/>
-            <a:ext cx="17364730" cy="3514725"/>
+            <a:off x="461635" y="3609975"/>
+            <a:ext cx="17364730" cy="3057525"/>
           </a:xfrm>
           <a:prstGeom prst="rect">
             <a:avLst/>
@@ -4642,10 +4638,10 @@
                 <a:solidFill>
                   <a:srgbClr val="000000"/>
                 </a:solidFill>
-                <a:latin typeface="Jua"/>
-                <a:ea typeface="Jua"/>
-                <a:cs typeface="Jua"/>
-                <a:sym typeface="Jua"/>
+                <a:latin typeface="무궁화 고딕"/>
+                <a:ea typeface="무궁화 고딕"/>
+                <a:cs typeface="무궁화 고딕"/>
+                <a:sym typeface="무궁화 고딕"/>
               </a:rPr>
               <a:t>ㅊㅋㅋㅇㅋ</a:t>
             </a:r>
@@ -4660,8 +4656,8 @@
         </p:nvSpPr>
         <p:spPr>
           <a:xfrm rot="0">
-            <a:off x="461635" y="6533441"/>
-            <a:ext cx="17364730" cy="1952625"/>
+            <a:off x="461635" y="6800141"/>
+            <a:ext cx="17364730" cy="1685925"/>
           </a:xfrm>
           <a:prstGeom prst="rect">
             <a:avLst/>
@@ -4683,10 +4679,10 @@
                 <a:solidFill>
                   <a:srgbClr val="000000"/>
                 </a:solidFill>
-                <a:latin typeface="Jua"/>
-                <a:ea typeface="Jua"/>
-                <a:cs typeface="Jua"/>
-                <a:sym typeface="Jua"/>
+                <a:latin typeface="무궁화 고딕"/>
+                <a:ea typeface="무궁화 고딕"/>
+                <a:cs typeface="무궁화 고딕"/>
+                <a:sym typeface="무궁화 고딕"/>
               </a:rPr>
               <a:t>Hint : 디저트</a:t>
             </a:r>
@@ -4835,8 +4831,8 @@
         </p:nvSpPr>
         <p:spPr>
           <a:xfrm rot="0">
-            <a:off x="11392761" y="600705"/>
-            <a:ext cx="5362043" cy="1600200"/>
+            <a:off x="11392761" y="819780"/>
+            <a:ext cx="5362043" cy="1381125"/>
           </a:xfrm>
           <a:prstGeom prst="rect">
             <a:avLst/>
@@ -4858,10 +4854,10 @@
                 <a:solidFill>
                   <a:srgbClr val="FFFAEF"/>
                 </a:solidFill>
-                <a:latin typeface="Jua"/>
-                <a:ea typeface="Jua"/>
-                <a:cs typeface="Jua"/>
-                <a:sym typeface="Jua"/>
+                <a:latin typeface="무궁화 고딕"/>
+                <a:ea typeface="무궁화 고딕"/>
+                <a:cs typeface="무궁화 고딕"/>
+                <a:sym typeface="무궁화 고딕"/>
               </a:rPr>
               <a:t>규칙</a:t>
             </a:r>
@@ -4877,9 +4873,9 @@
         <p:grpSpPr>
           <a:xfrm rot="0">
             <a:off x="309172" y="535073"/>
-            <a:ext cx="6944841" cy="1779769"/>
+            <a:ext cx="6944841" cy="1701684"/>
             <a:chOff x="0" y="0"/>
-            <a:chExt cx="9259787" cy="2373026"/>
+            <a:chExt cx="9259787" cy="2268911"/>
           </a:xfrm>
         </p:grpSpPr>
         <p:sp>
@@ -4890,8 +4886,8 @@
           </p:nvSpPr>
           <p:spPr>
             <a:xfrm rot="0">
-              <a:off x="0" y="1380584"/>
-              <a:ext cx="9259787" cy="992442"/>
+              <a:off x="0" y="1388378"/>
+              <a:ext cx="9259787" cy="880533"/>
             </a:xfrm>
             <a:prstGeom prst="rect">
               <a:avLst/>
@@ -4905,18 +4901,18 @@
             <a:p>
               <a:pPr algn="l">
                 <a:lnSpc>
-                  <a:spcPts val="6273"/>
+                  <a:spcPts val="5599"/>
                 </a:lnSpc>
               </a:pPr>
               <a:r>
-                <a:rPr lang="en-US" sz="4480">
+                <a:rPr lang="en-US" sz="3999">
                   <a:solidFill>
                     <a:srgbClr val="FFFAEF"/>
                   </a:solidFill>
-                  <a:latin typeface="TDTD가온"/>
-                  <a:ea typeface="TDTD가온"/>
-                  <a:cs typeface="TDTD가온"/>
-                  <a:sym typeface="TDTD가온"/>
+                  <a:latin typeface="무궁화 고딕"/>
+                  <a:ea typeface="무궁화 고딕"/>
+                  <a:cs typeface="무궁화 고딕"/>
+                  <a:sym typeface="무궁화 고딕"/>
                 </a:rPr>
                 <a:t>화면에 단어의 초성이 나타납니다.</a:t>
               </a:r>
@@ -4931,8 +4927,8 @@
           </p:nvSpPr>
           <p:spPr>
             <a:xfrm rot="0">
-              <a:off x="0" y="-171450"/>
-              <a:ext cx="6217692" cy="1169217"/>
+              <a:off x="0" y="-66675"/>
+              <a:ext cx="6217692" cy="1062712"/>
             </a:xfrm>
             <a:prstGeom prst="rect">
               <a:avLst/>
@@ -4954,10 +4950,10 @@
                   <a:solidFill>
                     <a:srgbClr val="FFFAEF"/>
                   </a:solidFill>
-                  <a:latin typeface="Jua"/>
-                  <a:ea typeface="Jua"/>
-                  <a:cs typeface="Jua"/>
-                  <a:sym typeface="Jua"/>
+                  <a:latin typeface="무궁화 고딕 Bold"/>
+                  <a:ea typeface="무궁화 고딕 Bold"/>
+                  <a:cs typeface="무궁화 고딕 Bold"/>
+                  <a:sym typeface="무궁화 고딕 Bold"/>
                 </a:rPr>
                 <a:t>STEP 1.</a:t>
               </a:r>
@@ -4974,9 +4970,9 @@
         <p:grpSpPr>
           <a:xfrm rot="0">
             <a:off x="10281405" y="8072734"/>
-            <a:ext cx="7584755" cy="1778769"/>
+            <a:ext cx="7584755" cy="1697862"/>
             <a:chOff x="0" y="0"/>
-            <a:chExt cx="10113007" cy="2371692"/>
+            <a:chExt cx="10113007" cy="2263816"/>
           </a:xfrm>
         </p:grpSpPr>
         <p:sp>
@@ -4987,8 +4983,8 @@
           </p:nvSpPr>
           <p:spPr>
             <a:xfrm rot="0">
-              <a:off x="0" y="1377534"/>
-              <a:ext cx="9958397" cy="994158"/>
+              <a:off x="0" y="1373758"/>
+              <a:ext cx="9958397" cy="890058"/>
             </a:xfrm>
             <a:prstGeom prst="rect">
               <a:avLst/>
@@ -5002,18 +4998,18 @@
             <a:p>
               <a:pPr algn="l">
                 <a:lnSpc>
-                  <a:spcPts val="6284"/>
+                  <a:spcPts val="5600"/>
                 </a:lnSpc>
               </a:pPr>
               <a:r>
-                <a:rPr lang="en-US" sz="4489">
+                <a:rPr lang="en-US" sz="4000">
                   <a:solidFill>
                     <a:srgbClr val="FFFAEF"/>
                   </a:solidFill>
-                  <a:latin typeface="TDTD가온"/>
-                  <a:ea typeface="TDTD가온"/>
-                  <a:cs typeface="TDTD가온"/>
-                  <a:sym typeface="TDTD가온"/>
+                  <a:latin typeface="무궁화 고딕"/>
+                  <a:ea typeface="무궁화 고딕"/>
+                  <a:cs typeface="무궁화 고딕"/>
+                  <a:sym typeface="무궁화 고딕"/>
                 </a:rPr>
                 <a:t>가장 많은 점수를 얻은 팀이 우승!</a:t>
               </a:r>
@@ -5028,8 +5024,8 @@
           </p:nvSpPr>
           <p:spPr>
             <a:xfrm rot="0">
-              <a:off x="0" y="-171450"/>
-              <a:ext cx="10113007" cy="1171105"/>
+              <a:off x="0" y="-57150"/>
+              <a:ext cx="10113007" cy="1053029"/>
             </a:xfrm>
             <a:prstGeom prst="rect">
               <a:avLst/>
@@ -5051,10 +5047,10 @@
                   <a:solidFill>
                     <a:srgbClr val="FFFAEF"/>
                   </a:solidFill>
-                  <a:latin typeface="Jua"/>
-                  <a:ea typeface="Jua"/>
-                  <a:cs typeface="Jua"/>
-                  <a:sym typeface="Jua"/>
+                  <a:latin typeface="무궁화 고딕 Bold"/>
+                  <a:ea typeface="무궁화 고딕 Bold"/>
+                  <a:cs typeface="무궁화 고딕 Bold"/>
+                  <a:sym typeface="무궁화 고딕 Bold"/>
                 </a:rPr>
                 <a:t>STEP 3.</a:t>
               </a:r>
@@ -5071,9 +5067,9 @@
         <p:grpSpPr>
           <a:xfrm rot="0">
             <a:off x="5198474" y="3908765"/>
-            <a:ext cx="7891051" cy="2570047"/>
+            <a:ext cx="7891051" cy="2402261"/>
             <a:chOff x="0" y="0"/>
-            <a:chExt cx="10521401" cy="3426730"/>
+            <a:chExt cx="10521401" cy="3203015"/>
           </a:xfrm>
         </p:grpSpPr>
         <p:sp>
@@ -5084,8 +5080,8 @@
           </p:nvSpPr>
           <p:spPr>
             <a:xfrm rot="0">
-              <a:off x="0" y="1375218"/>
-              <a:ext cx="10521401" cy="2051512"/>
+              <a:off x="0" y="1382681"/>
+              <a:ext cx="10521401" cy="1820333"/>
             </a:xfrm>
             <a:prstGeom prst="rect">
               <a:avLst/>
@@ -5099,18 +5095,18 @@
             <a:p>
               <a:pPr algn="l">
                 <a:lnSpc>
-                  <a:spcPts val="6275"/>
+                  <a:spcPts val="5599"/>
                 </a:lnSpc>
               </a:pPr>
               <a:r>
-                <a:rPr lang="en-US" sz="4482">
+                <a:rPr lang="en-US" sz="3999">
                   <a:solidFill>
                     <a:srgbClr val="FFFAEF"/>
                   </a:solidFill>
-                  <a:latin typeface="TDTD가온"/>
-                  <a:ea typeface="TDTD가온"/>
-                  <a:cs typeface="TDTD가온"/>
-                  <a:sym typeface="TDTD가온"/>
+                  <a:latin typeface="무궁화 고딕"/>
+                  <a:ea typeface="무궁화 고딕"/>
+                  <a:cs typeface="무궁화 고딕"/>
+                  <a:sym typeface="무궁화 고딕"/>
                 </a:rPr>
                 <a:t>팀 구호를 외치거나 정답을 가장 먼저</a:t>
               </a:r>
@@ -5118,18 +5114,18 @@
             <a:p>
               <a:pPr algn="l">
                 <a:lnSpc>
-                  <a:spcPts val="6275"/>
+                  <a:spcPts val="5599"/>
                 </a:lnSpc>
               </a:pPr>
               <a:r>
-                <a:rPr lang="en-US" sz="4482">
+                <a:rPr lang="en-US" sz="3999">
                   <a:solidFill>
                     <a:srgbClr val="FFFAEF"/>
                   </a:solidFill>
-                  <a:latin typeface="TDTD가온"/>
-                  <a:ea typeface="TDTD가온"/>
-                  <a:cs typeface="TDTD가온"/>
-                  <a:sym typeface="TDTD가온"/>
+                  <a:latin typeface="무궁화 고딕"/>
+                  <a:ea typeface="무궁화 고딕"/>
+                  <a:cs typeface="무궁화 고딕"/>
+                  <a:sym typeface="무궁화 고딕"/>
                 </a:rPr>
                 <a:t>외친 팀에게 기회가 주어집니다.</a:t>
               </a:r>
@@ -5144,8 +5140,8 @@
           </p:nvSpPr>
           <p:spPr>
             <a:xfrm rot="0">
-              <a:off x="0" y="-171450"/>
-              <a:ext cx="6486548" cy="1169523"/>
+              <a:off x="0" y="-57150"/>
+              <a:ext cx="6486548" cy="1053161"/>
             </a:xfrm>
             <a:prstGeom prst="rect">
               <a:avLst/>
@@ -5167,10 +5163,10 @@
                   <a:solidFill>
                     <a:srgbClr val="FFFAEF"/>
                   </a:solidFill>
-                  <a:latin typeface="Jua"/>
-                  <a:ea typeface="Jua"/>
-                  <a:cs typeface="Jua"/>
-                  <a:sym typeface="Jua"/>
+                  <a:latin typeface="무궁화 고딕 Bold"/>
+                  <a:ea typeface="무궁화 고딕 Bold"/>
+                  <a:cs typeface="무궁화 고딕 Bold"/>
+                  <a:sym typeface="무궁화 고딕 Bold"/>
                 </a:rPr>
                 <a:t>STEP 2.</a:t>
               </a:r>
@@ -5268,8 +5264,8 @@
         </p:nvSpPr>
         <p:spPr>
           <a:xfrm rot="0">
-            <a:off x="461635" y="3152775"/>
-            <a:ext cx="17364730" cy="3514725"/>
+            <a:off x="461635" y="3609975"/>
+            <a:ext cx="17364730" cy="3057525"/>
           </a:xfrm>
           <a:prstGeom prst="rect">
             <a:avLst/>
@@ -5291,10 +5287,10 @@
                 <a:solidFill>
                   <a:srgbClr val="000000"/>
                 </a:solidFill>
-                <a:latin typeface="Jua"/>
-                <a:ea typeface="Jua"/>
-                <a:cs typeface="Jua"/>
-                <a:sym typeface="Jua"/>
+                <a:latin typeface="무궁화 고딕"/>
+                <a:ea typeface="무궁화 고딕"/>
+                <a:cs typeface="무궁화 고딕"/>
+                <a:sym typeface="무궁화 고딕"/>
               </a:rPr>
               <a:t>초코케이크</a:t>
             </a:r>
@@ -5391,8 +5387,8 @@
         </p:nvSpPr>
         <p:spPr>
           <a:xfrm rot="0">
-            <a:off x="461635" y="3895725"/>
-            <a:ext cx="17364730" cy="2200275"/>
+            <a:off x="461635" y="4181475"/>
+            <a:ext cx="17364730" cy="1914525"/>
           </a:xfrm>
           <a:prstGeom prst="rect">
             <a:avLst/>
@@ -5414,10 +5410,10 @@
                 <a:solidFill>
                   <a:srgbClr val="000000"/>
                 </a:solidFill>
-                <a:latin typeface="Jua"/>
-                <a:ea typeface="Jua"/>
-                <a:cs typeface="Jua"/>
-                <a:sym typeface="Jua"/>
+                <a:latin typeface="무궁화 고딕"/>
+                <a:ea typeface="무궁화 고딕"/>
+                <a:cs typeface="무궁화 고딕"/>
+                <a:sym typeface="무궁화 고딕"/>
               </a:rPr>
               <a:t>카테고리 : 🐾 동물 🐾</a:t>
             </a:r>
@@ -5514,8 +5510,8 @@
         </p:nvSpPr>
         <p:spPr>
           <a:xfrm rot="0">
-            <a:off x="461635" y="3152775"/>
-            <a:ext cx="17364730" cy="3514725"/>
+            <a:off x="461635" y="3609975"/>
+            <a:ext cx="17364730" cy="3057525"/>
           </a:xfrm>
           <a:prstGeom prst="rect">
             <a:avLst/>
@@ -5537,10 +5533,10 @@
                 <a:solidFill>
                   <a:srgbClr val="000000"/>
                 </a:solidFill>
-                <a:latin typeface="Jua"/>
-                <a:ea typeface="Jua"/>
-                <a:cs typeface="Jua"/>
-                <a:sym typeface="Jua"/>
+                <a:latin typeface="무궁화 고딕"/>
+                <a:ea typeface="무궁화 고딕"/>
+                <a:cs typeface="무궁화 고딕"/>
+                <a:sym typeface="무궁화 고딕"/>
               </a:rPr>
               <a:t>ㅎㄹㅇ</a:t>
             </a:r>
@@ -5637,8 +5633,8 @@
         </p:nvSpPr>
         <p:spPr>
           <a:xfrm rot="0">
-            <a:off x="461635" y="3152775"/>
-            <a:ext cx="17364730" cy="3514725"/>
+            <a:off x="461635" y="3609975"/>
+            <a:ext cx="17364730" cy="3057525"/>
           </a:xfrm>
           <a:prstGeom prst="rect">
             <a:avLst/>
@@ -5660,10 +5656,10 @@
                 <a:solidFill>
                   <a:srgbClr val="000000"/>
                 </a:solidFill>
-                <a:latin typeface="Jua"/>
-                <a:ea typeface="Jua"/>
-                <a:cs typeface="Jua"/>
-                <a:sym typeface="Jua"/>
+                <a:latin typeface="무궁화 고딕"/>
+                <a:ea typeface="무궁화 고딕"/>
+                <a:cs typeface="무궁화 고딕"/>
+                <a:sym typeface="무궁화 고딕"/>
               </a:rPr>
               <a:t>ㅎㄹㅇ</a:t>
             </a:r>
@@ -5678,8 +5674,8 @@
         </p:nvSpPr>
         <p:spPr>
           <a:xfrm rot="0">
-            <a:off x="461635" y="6533441"/>
-            <a:ext cx="17364730" cy="1952625"/>
+            <a:off x="461635" y="6800141"/>
+            <a:ext cx="17364730" cy="1685925"/>
           </a:xfrm>
           <a:prstGeom prst="rect">
             <a:avLst/>
@@ -5701,10 +5697,10 @@
                 <a:solidFill>
                   <a:srgbClr val="000000"/>
                 </a:solidFill>
-                <a:latin typeface="Jua"/>
-                <a:ea typeface="Jua"/>
-                <a:cs typeface="Jua"/>
-                <a:sym typeface="Jua"/>
+                <a:latin typeface="무궁화 고딕"/>
+                <a:ea typeface="무궁화 고딕"/>
+                <a:cs typeface="무궁화 고딕"/>
+                <a:sym typeface="무궁화 고딕"/>
               </a:rPr>
               <a:t>Hint : 맹수</a:t>
             </a:r>
@@ -5801,8 +5797,8 @@
         </p:nvSpPr>
         <p:spPr>
           <a:xfrm rot="0">
-            <a:off x="461635" y="3152775"/>
-            <a:ext cx="17364730" cy="3514725"/>
+            <a:off x="461635" y="3609975"/>
+            <a:ext cx="17364730" cy="3057525"/>
           </a:xfrm>
           <a:prstGeom prst="rect">
             <a:avLst/>
@@ -5824,10 +5820,10 @@
                 <a:solidFill>
                   <a:srgbClr val="000000"/>
                 </a:solidFill>
-                <a:latin typeface="Jua"/>
-                <a:ea typeface="Jua"/>
-                <a:cs typeface="Jua"/>
-                <a:sym typeface="Jua"/>
+                <a:latin typeface="무궁화 고딕"/>
+                <a:ea typeface="무궁화 고딕"/>
+                <a:cs typeface="무궁화 고딕"/>
+                <a:sym typeface="무궁화 고딕"/>
               </a:rPr>
               <a:t>호랑이</a:t>
             </a:r>
@@ -5924,8 +5920,8 @@
         </p:nvSpPr>
         <p:spPr>
           <a:xfrm rot="0">
-            <a:off x="461635" y="3152775"/>
-            <a:ext cx="17364730" cy="3514725"/>
+            <a:off x="461635" y="3609975"/>
+            <a:ext cx="17364730" cy="3057525"/>
           </a:xfrm>
           <a:prstGeom prst="rect">
             <a:avLst/>
@@ -5947,10 +5943,10 @@
                 <a:solidFill>
                   <a:srgbClr val="000000"/>
                 </a:solidFill>
-                <a:latin typeface="Jua"/>
-                <a:ea typeface="Jua"/>
-                <a:cs typeface="Jua"/>
-                <a:sym typeface="Jua"/>
+                <a:latin typeface="무궁화 고딕"/>
+                <a:ea typeface="무궁화 고딕"/>
+                <a:cs typeface="무궁화 고딕"/>
+                <a:sym typeface="무궁화 고딕"/>
               </a:rPr>
               <a:t>ㅋㄲㄹ</a:t>
             </a:r>
@@ -6047,8 +6043,8 @@
         </p:nvSpPr>
         <p:spPr>
           <a:xfrm rot="0">
-            <a:off x="461635" y="3152775"/>
-            <a:ext cx="17364730" cy="3514725"/>
+            <a:off x="461635" y="3609975"/>
+            <a:ext cx="17364730" cy="3057525"/>
           </a:xfrm>
           <a:prstGeom prst="rect">
             <a:avLst/>
@@ -6070,10 +6066,10 @@
                 <a:solidFill>
                   <a:srgbClr val="000000"/>
                 </a:solidFill>
-                <a:latin typeface="Jua"/>
-                <a:ea typeface="Jua"/>
-                <a:cs typeface="Jua"/>
-                <a:sym typeface="Jua"/>
+                <a:latin typeface="무궁화 고딕"/>
+                <a:ea typeface="무궁화 고딕"/>
+                <a:cs typeface="무궁화 고딕"/>
+                <a:sym typeface="무궁화 고딕"/>
               </a:rPr>
               <a:t>ㅋㄲㄹ</a:t>
             </a:r>
@@ -6088,8 +6084,8 @@
         </p:nvSpPr>
         <p:spPr>
           <a:xfrm rot="0">
-            <a:off x="461635" y="6533441"/>
-            <a:ext cx="17364730" cy="1952625"/>
+            <a:off x="499735" y="6800141"/>
+            <a:ext cx="17364730" cy="1685925"/>
           </a:xfrm>
           <a:prstGeom prst="rect">
             <a:avLst/>
@@ -6111,10 +6107,10 @@
                 <a:solidFill>
                   <a:srgbClr val="000000"/>
                 </a:solidFill>
-                <a:latin typeface="Jua"/>
-                <a:ea typeface="Jua"/>
-                <a:cs typeface="Jua"/>
-                <a:sym typeface="Jua"/>
+                <a:latin typeface="무궁화 고딕"/>
+                <a:ea typeface="무궁화 고딕"/>
+                <a:cs typeface="무궁화 고딕"/>
+                <a:sym typeface="무궁화 고딕"/>
               </a:rPr>
               <a:t>Hint : 코가 길어요</a:t>
             </a:r>
@@ -6211,8 +6207,8 @@
         </p:nvSpPr>
         <p:spPr>
           <a:xfrm rot="0">
-            <a:off x="461635" y="3152775"/>
-            <a:ext cx="17364730" cy="3514725"/>
+            <a:off x="461635" y="3609975"/>
+            <a:ext cx="17364730" cy="3057525"/>
           </a:xfrm>
           <a:prstGeom prst="rect">
             <a:avLst/>
@@ -6234,10 +6230,10 @@
                 <a:solidFill>
                   <a:srgbClr val="000000"/>
                 </a:solidFill>
-                <a:latin typeface="Jua"/>
-                <a:ea typeface="Jua"/>
-                <a:cs typeface="Jua"/>
-                <a:sym typeface="Jua"/>
+                <a:latin typeface="무궁화 고딕"/>
+                <a:ea typeface="무궁화 고딕"/>
+                <a:cs typeface="무궁화 고딕"/>
+                <a:sym typeface="무궁화 고딕"/>
               </a:rPr>
               <a:t>코끼리</a:t>
             </a:r>
@@ -6334,8 +6330,8 @@
         </p:nvSpPr>
         <p:spPr>
           <a:xfrm rot="0">
-            <a:off x="461635" y="3152775"/>
-            <a:ext cx="17364730" cy="3514725"/>
+            <a:off x="461635" y="3609975"/>
+            <a:ext cx="17364730" cy="3057525"/>
           </a:xfrm>
           <a:prstGeom prst="rect">
             <a:avLst/>
@@ -6357,10 +6353,10 @@
                 <a:solidFill>
                   <a:srgbClr val="000000"/>
                 </a:solidFill>
-                <a:latin typeface="Jua"/>
-                <a:ea typeface="Jua"/>
-                <a:cs typeface="Jua"/>
-                <a:sym typeface="Jua"/>
+                <a:latin typeface="무궁화 고딕"/>
+                <a:ea typeface="무궁화 고딕"/>
+                <a:cs typeface="무궁화 고딕"/>
+                <a:sym typeface="무궁화 고딕"/>
               </a:rPr>
               <a:t>ㅍㄱ</a:t>
             </a:r>
@@ -6457,8 +6453,8 @@
         </p:nvSpPr>
         <p:spPr>
           <a:xfrm rot="0">
-            <a:off x="461635" y="3152775"/>
-            <a:ext cx="17364730" cy="3514725"/>
+            <a:off x="461635" y="3609975"/>
+            <a:ext cx="17364730" cy="3057525"/>
           </a:xfrm>
           <a:prstGeom prst="rect">
             <a:avLst/>
@@ -6480,10 +6476,10 @@
                 <a:solidFill>
                   <a:srgbClr val="000000"/>
                 </a:solidFill>
-                <a:latin typeface="Jua"/>
-                <a:ea typeface="Jua"/>
-                <a:cs typeface="Jua"/>
-                <a:sym typeface="Jua"/>
+                <a:latin typeface="무궁화 고딕"/>
+                <a:ea typeface="무궁화 고딕"/>
+                <a:cs typeface="무궁화 고딕"/>
+                <a:sym typeface="무궁화 고딕"/>
               </a:rPr>
               <a:t>ㅍㄱ</a:t>
             </a:r>
@@ -6498,8 +6494,8 @@
         </p:nvSpPr>
         <p:spPr>
           <a:xfrm rot="0">
-            <a:off x="461635" y="6533441"/>
-            <a:ext cx="17364730" cy="1952625"/>
+            <a:off x="461635" y="6800141"/>
+            <a:ext cx="17364730" cy="1685925"/>
           </a:xfrm>
           <a:prstGeom prst="rect">
             <a:avLst/>
@@ -6521,10 +6517,10 @@
                 <a:solidFill>
                   <a:srgbClr val="000000"/>
                 </a:solidFill>
-                <a:latin typeface="Jua"/>
-                <a:ea typeface="Jua"/>
-                <a:cs typeface="Jua"/>
-                <a:sym typeface="Jua"/>
+                <a:latin typeface="무궁화 고딕"/>
+                <a:ea typeface="무궁화 고딕"/>
+                <a:cs typeface="무궁화 고딕"/>
+                <a:sym typeface="무궁화 고딕"/>
               </a:rPr>
               <a:t>Hint : 뒤뚱뒤뚱</a:t>
             </a:r>
@@ -6571,8 +6567,8 @@
         </p:nvSpPr>
         <p:spPr>
           <a:xfrm rot="0">
-            <a:off x="3238925" y="4092795"/>
-            <a:ext cx="11810151" cy="2200275"/>
+            <a:off x="3238925" y="4378545"/>
+            <a:ext cx="11810151" cy="1914525"/>
           </a:xfrm>
           <a:prstGeom prst="rect">
             <a:avLst/>
@@ -6594,10 +6590,10 @@
                 <a:solidFill>
                   <a:srgbClr val="000000"/>
                 </a:solidFill>
-                <a:latin typeface="Jua"/>
-                <a:ea typeface="Jua"/>
-                <a:cs typeface="Jua"/>
-                <a:sym typeface="Jua"/>
+                <a:latin typeface="무궁화 고딕"/>
+                <a:ea typeface="무궁화 고딕"/>
+                <a:cs typeface="무궁화 고딕"/>
+                <a:sym typeface="무궁화 고딕"/>
               </a:rPr>
               <a:t>팀을 나눠주세요!</a:t>
             </a:r>
@@ -6744,8 +6740,8 @@
         </p:nvSpPr>
         <p:spPr>
           <a:xfrm rot="0">
-            <a:off x="461635" y="3152775"/>
-            <a:ext cx="17364730" cy="3514725"/>
+            <a:off x="461635" y="3609975"/>
+            <a:ext cx="17364730" cy="3057525"/>
           </a:xfrm>
           <a:prstGeom prst="rect">
             <a:avLst/>
@@ -6767,10 +6763,10 @@
                 <a:solidFill>
                   <a:srgbClr val="000000"/>
                 </a:solidFill>
-                <a:latin typeface="Jua"/>
-                <a:ea typeface="Jua"/>
-                <a:cs typeface="Jua"/>
-                <a:sym typeface="Jua"/>
+                <a:latin typeface="무궁화 고딕"/>
+                <a:ea typeface="무궁화 고딕"/>
+                <a:cs typeface="무궁화 고딕"/>
+                <a:sym typeface="무궁화 고딕"/>
               </a:rPr>
               <a:t>펭귄</a:t>
             </a:r>
@@ -6867,8 +6863,8 @@
         </p:nvSpPr>
         <p:spPr>
           <a:xfrm rot="0">
-            <a:off x="461635" y="3152775"/>
-            <a:ext cx="17364730" cy="3514725"/>
+            <a:off x="461635" y="3609975"/>
+            <a:ext cx="17364730" cy="3057525"/>
           </a:xfrm>
           <a:prstGeom prst="rect">
             <a:avLst/>
@@ -6890,10 +6886,10 @@
                 <a:solidFill>
                   <a:srgbClr val="000000"/>
                 </a:solidFill>
-                <a:latin typeface="Jua"/>
-                <a:ea typeface="Jua"/>
-                <a:cs typeface="Jua"/>
-                <a:sym typeface="Jua"/>
+                <a:latin typeface="무궁화 고딕"/>
+                <a:ea typeface="무궁화 고딕"/>
+                <a:cs typeface="무궁화 고딕"/>
+                <a:sym typeface="무궁화 고딕"/>
               </a:rPr>
               <a:t>ㅋㅇㅌ</a:t>
             </a:r>
@@ -6990,8 +6986,8 @@
         </p:nvSpPr>
         <p:spPr>
           <a:xfrm rot="0">
-            <a:off x="461635" y="3152775"/>
-            <a:ext cx="17364730" cy="3514725"/>
+            <a:off x="461635" y="3609975"/>
+            <a:ext cx="17364730" cy="3057525"/>
           </a:xfrm>
           <a:prstGeom prst="rect">
             <a:avLst/>
@@ -7013,10 +7009,10 @@
                 <a:solidFill>
                   <a:srgbClr val="000000"/>
                 </a:solidFill>
-                <a:latin typeface="Jua"/>
-                <a:ea typeface="Jua"/>
-                <a:cs typeface="Jua"/>
-                <a:sym typeface="Jua"/>
+                <a:latin typeface="무궁화 고딕"/>
+                <a:ea typeface="무궁화 고딕"/>
+                <a:cs typeface="무궁화 고딕"/>
+                <a:sym typeface="무궁화 고딕"/>
               </a:rPr>
               <a:t>ㅋㅇㅌ</a:t>
             </a:r>
@@ -7031,8 +7027,8 @@
         </p:nvSpPr>
         <p:spPr>
           <a:xfrm rot="0">
-            <a:off x="461635" y="6533441"/>
-            <a:ext cx="17364730" cy="1952625"/>
+            <a:off x="461635" y="6800141"/>
+            <a:ext cx="17364730" cy="1685925"/>
           </a:xfrm>
           <a:prstGeom prst="rect">
             <a:avLst/>
@@ -7054,10 +7050,10 @@
                 <a:solidFill>
                   <a:srgbClr val="000000"/>
                 </a:solidFill>
-                <a:latin typeface="Jua"/>
-                <a:ea typeface="Jua"/>
-                <a:cs typeface="Jua"/>
-                <a:sym typeface="Jua"/>
+                <a:latin typeface="무궁화 고딕"/>
+                <a:ea typeface="무궁화 고딕"/>
+                <a:cs typeface="무궁화 고딕"/>
+                <a:sym typeface="무궁화 고딕"/>
               </a:rPr>
               <a:t>Hint : 혼성그룹</a:t>
             </a:r>
@@ -7154,8 +7150,8 @@
         </p:nvSpPr>
         <p:spPr>
           <a:xfrm rot="0">
-            <a:off x="461635" y="3152775"/>
-            <a:ext cx="17364730" cy="3514725"/>
+            <a:off x="461635" y="3609975"/>
+            <a:ext cx="17364730" cy="3057525"/>
           </a:xfrm>
           <a:prstGeom prst="rect">
             <a:avLst/>
@@ -7177,10 +7173,10 @@
                 <a:solidFill>
                   <a:srgbClr val="000000"/>
                 </a:solidFill>
-                <a:latin typeface="Jua"/>
-                <a:ea typeface="Jua"/>
-                <a:cs typeface="Jua"/>
-                <a:sym typeface="Jua"/>
+                <a:latin typeface="무궁화 고딕"/>
+                <a:ea typeface="무궁화 고딕"/>
+                <a:cs typeface="무궁화 고딕"/>
+                <a:sym typeface="무궁화 고딕"/>
               </a:rPr>
               <a:t>코요태</a:t>
             </a:r>
@@ -7277,8 +7273,8 @@
         </p:nvSpPr>
         <p:spPr>
           <a:xfrm rot="0">
-            <a:off x="461635" y="3152775"/>
-            <a:ext cx="17364730" cy="3514725"/>
+            <a:off x="461635" y="3609975"/>
+            <a:ext cx="17364730" cy="3057525"/>
           </a:xfrm>
           <a:prstGeom prst="rect">
             <a:avLst/>
@@ -7300,10 +7296,10 @@
                 <a:solidFill>
                   <a:srgbClr val="000000"/>
                 </a:solidFill>
-                <a:latin typeface="Jua"/>
-                <a:ea typeface="Jua"/>
-                <a:cs typeface="Jua"/>
-                <a:sym typeface="Jua"/>
+                <a:latin typeface="무궁화 고딕"/>
+                <a:ea typeface="무궁화 고딕"/>
+                <a:cs typeface="무궁화 고딕"/>
+                <a:sym typeface="무궁화 고딕"/>
               </a:rPr>
               <a:t>ㅊㅍㅈ</a:t>
             </a:r>
@@ -7400,8 +7396,8 @@
         </p:nvSpPr>
         <p:spPr>
           <a:xfrm rot="0">
-            <a:off x="461635" y="6533441"/>
-            <a:ext cx="17364730" cy="1952625"/>
+            <a:off x="461635" y="6800141"/>
+            <a:ext cx="17364730" cy="1685925"/>
           </a:xfrm>
           <a:prstGeom prst="rect">
             <a:avLst/>
@@ -7423,10 +7419,10 @@
                 <a:solidFill>
                   <a:srgbClr val="000000"/>
                 </a:solidFill>
-                <a:latin typeface="Jua"/>
-                <a:ea typeface="Jua"/>
-                <a:cs typeface="Jua"/>
-                <a:sym typeface="Jua"/>
+                <a:latin typeface="무궁화 고딕"/>
+                <a:ea typeface="무궁화 고딕"/>
+                <a:cs typeface="무궁화 고딕"/>
+                <a:sym typeface="무궁화 고딕"/>
               </a:rPr>
               <a:t>Hint : 사람과 비슷해요</a:t>
             </a:r>
@@ -7441,8 +7437,8 @@
         </p:nvSpPr>
         <p:spPr>
           <a:xfrm rot="0">
-            <a:off x="461635" y="3152775"/>
-            <a:ext cx="17364730" cy="3514725"/>
+            <a:off x="461635" y="3609975"/>
+            <a:ext cx="17364730" cy="3057525"/>
           </a:xfrm>
           <a:prstGeom prst="rect">
             <a:avLst/>
@@ -7464,10 +7460,10 @@
                 <a:solidFill>
                   <a:srgbClr val="000000"/>
                 </a:solidFill>
-                <a:latin typeface="Jua"/>
-                <a:ea typeface="Jua"/>
-                <a:cs typeface="Jua"/>
-                <a:sym typeface="Jua"/>
+                <a:latin typeface="무궁화 고딕"/>
+                <a:ea typeface="무궁화 고딕"/>
+                <a:cs typeface="무궁화 고딕"/>
+                <a:sym typeface="무궁화 고딕"/>
               </a:rPr>
               <a:t>ㅊㅍㅈ</a:t>
             </a:r>
@@ -7564,8 +7560,8 @@
         </p:nvSpPr>
         <p:spPr>
           <a:xfrm rot="0">
-            <a:off x="461635" y="3152775"/>
-            <a:ext cx="17364730" cy="3514725"/>
+            <a:off x="461635" y="3609975"/>
+            <a:ext cx="17364730" cy="3057525"/>
           </a:xfrm>
           <a:prstGeom prst="rect">
             <a:avLst/>
@@ -7587,10 +7583,10 @@
                 <a:solidFill>
                   <a:srgbClr val="000000"/>
                 </a:solidFill>
-                <a:latin typeface="Jua"/>
-                <a:ea typeface="Jua"/>
-                <a:cs typeface="Jua"/>
-                <a:sym typeface="Jua"/>
+                <a:latin typeface="무궁화 고딕"/>
+                <a:ea typeface="무궁화 고딕"/>
+                <a:cs typeface="무궁화 고딕"/>
+                <a:sym typeface="무궁화 고딕"/>
               </a:rPr>
               <a:t>침팬지</a:t>
             </a:r>
@@ -7687,8 +7683,8 @@
         </p:nvSpPr>
         <p:spPr>
           <a:xfrm rot="0">
-            <a:off x="461635" y="3895725"/>
-            <a:ext cx="17364730" cy="2200275"/>
+            <a:off x="461635" y="4181475"/>
+            <a:ext cx="17364730" cy="1914525"/>
           </a:xfrm>
           <a:prstGeom prst="rect">
             <a:avLst/>
@@ -7710,10 +7706,10 @@
                 <a:solidFill>
                   <a:srgbClr val="000000"/>
                 </a:solidFill>
-                <a:latin typeface="Jua"/>
-                <a:ea typeface="Jua"/>
-                <a:cs typeface="Jua"/>
-                <a:sym typeface="Jua"/>
+                <a:latin typeface="무궁화 고딕"/>
+                <a:ea typeface="무궁화 고딕"/>
+                <a:cs typeface="무궁화 고딕"/>
+                <a:sym typeface="무궁화 고딕"/>
               </a:rPr>
               <a:t>카테고리 : 📍 장소 📍</a:t>
             </a:r>
@@ -7810,8 +7806,8 @@
         </p:nvSpPr>
         <p:spPr>
           <a:xfrm rot="0">
-            <a:off x="461635" y="3152775"/>
-            <a:ext cx="17364730" cy="3514725"/>
+            <a:off x="461635" y="3609975"/>
+            <a:ext cx="17364730" cy="3057525"/>
           </a:xfrm>
           <a:prstGeom prst="rect">
             <a:avLst/>
@@ -7833,10 +7829,10 @@
                 <a:solidFill>
                   <a:srgbClr val="000000"/>
                 </a:solidFill>
-                <a:latin typeface="Jua"/>
-                <a:ea typeface="Jua"/>
-                <a:cs typeface="Jua"/>
-                <a:sym typeface="Jua"/>
+                <a:latin typeface="무궁화 고딕"/>
+                <a:ea typeface="무궁화 고딕"/>
+                <a:cs typeface="무궁화 고딕"/>
+                <a:sym typeface="무궁화 고딕"/>
               </a:rPr>
               <a:t>ㄴㅇㄱㅇ</a:t>
             </a:r>
@@ -7933,8 +7929,8 @@
         </p:nvSpPr>
         <p:spPr>
           <a:xfrm rot="0">
-            <a:off x="461635" y="3152775"/>
-            <a:ext cx="17364730" cy="3514725"/>
+            <a:off x="461635" y="3609975"/>
+            <a:ext cx="17364730" cy="3057525"/>
           </a:xfrm>
           <a:prstGeom prst="rect">
             <a:avLst/>
@@ -7956,10 +7952,10 @@
                 <a:solidFill>
                   <a:srgbClr val="000000"/>
                 </a:solidFill>
-                <a:latin typeface="Jua"/>
-                <a:ea typeface="Jua"/>
-                <a:cs typeface="Jua"/>
-                <a:sym typeface="Jua"/>
+                <a:latin typeface="무궁화 고딕"/>
+                <a:ea typeface="무궁화 고딕"/>
+                <a:cs typeface="무궁화 고딕"/>
+                <a:sym typeface="무궁화 고딕"/>
               </a:rPr>
               <a:t>ㄴㅇㄱㅇ</a:t>
             </a:r>
@@ -7974,8 +7970,8 @@
         </p:nvSpPr>
         <p:spPr>
           <a:xfrm rot="0">
-            <a:off x="461635" y="6533441"/>
-            <a:ext cx="17364730" cy="1952625"/>
+            <a:off x="461635" y="6800141"/>
+            <a:ext cx="17364730" cy="1685925"/>
           </a:xfrm>
           <a:prstGeom prst="rect">
             <a:avLst/>
@@ -7997,10 +7993,10 @@
                 <a:solidFill>
                   <a:srgbClr val="000000"/>
                 </a:solidFill>
-                <a:latin typeface="Jua"/>
-                <a:ea typeface="Jua"/>
-                <a:cs typeface="Jua"/>
-                <a:sym typeface="Jua"/>
+                <a:latin typeface="무궁화 고딕"/>
+                <a:ea typeface="무궁화 고딕"/>
+                <a:cs typeface="무궁화 고딕"/>
+                <a:sym typeface="무궁화 고딕"/>
               </a:rPr>
               <a:t>Hint : 놀러가요</a:t>
             </a:r>
@@ -8097,8 +8093,8 @@
         </p:nvSpPr>
         <p:spPr>
           <a:xfrm rot="0">
-            <a:off x="1028700" y="3892867"/>
-            <a:ext cx="15555091" cy="2200275"/>
+            <a:off x="1028700" y="4178617"/>
+            <a:ext cx="15555091" cy="1914525"/>
           </a:xfrm>
           <a:prstGeom prst="rect">
             <a:avLst/>
@@ -8120,10 +8116,10 @@
                 <a:solidFill>
                   <a:srgbClr val="FFFAEF"/>
                 </a:solidFill>
-                <a:latin typeface="Jua"/>
-                <a:ea typeface="Jua"/>
-                <a:cs typeface="Jua"/>
-                <a:sym typeface="Jua"/>
+                <a:latin typeface="무궁화 고딕"/>
+                <a:ea typeface="무궁화 고딕"/>
+                <a:cs typeface="무궁화 고딕"/>
+                <a:sym typeface="무궁화 고딕"/>
               </a:rPr>
               <a:t>초성 퀴즈</a:t>
             </a:r>
@@ -8138,8 +8134,8 @@
         </p:nvSpPr>
         <p:spPr>
           <a:xfrm rot="0">
-            <a:off x="15264803" y="9812655"/>
-            <a:ext cx="2637975" cy="474345"/>
+            <a:off x="14542909" y="9822180"/>
+            <a:ext cx="3359870" cy="464820"/>
           </a:xfrm>
           <a:prstGeom prst="rect">
             <a:avLst/>
@@ -8164,10 +8160,10 @@
                 <a:solidFill>
                   <a:srgbClr val="FFFFFF"/>
                 </a:solidFill>
-                <a:latin typeface="TDTD갬성명조"/>
-                <a:ea typeface="TDTD갬성명조"/>
-                <a:cs typeface="TDTD갬성명조"/>
-                <a:sym typeface="TDTD갬성명조"/>
+                <a:latin typeface="무궁화 고딕"/>
+                <a:ea typeface="무궁화 고딕"/>
+                <a:cs typeface="무궁화 고딕"/>
+                <a:sym typeface="무궁화 고딕"/>
               </a:rPr>
               <a:t>ⓒ 2026. Sunday Play</a:t>
             </a:r>
@@ -8264,8 +8260,8 @@
         </p:nvSpPr>
         <p:spPr>
           <a:xfrm rot="0">
-            <a:off x="461635" y="3152775"/>
-            <a:ext cx="17364730" cy="3514725"/>
+            <a:off x="461635" y="3609975"/>
+            <a:ext cx="17364730" cy="3057525"/>
           </a:xfrm>
           <a:prstGeom prst="rect">
             <a:avLst/>
@@ -8287,10 +8283,10 @@
                 <a:solidFill>
                   <a:srgbClr val="000000"/>
                 </a:solidFill>
-                <a:latin typeface="Jua"/>
-                <a:ea typeface="Jua"/>
-                <a:cs typeface="Jua"/>
-                <a:sym typeface="Jua"/>
+                <a:latin typeface="무궁화 고딕"/>
+                <a:ea typeface="무궁화 고딕"/>
+                <a:cs typeface="무궁화 고딕"/>
+                <a:sym typeface="무궁화 고딕"/>
               </a:rPr>
               <a:t>놀이공원</a:t>
             </a:r>
@@ -8387,8 +8383,8 @@
         </p:nvSpPr>
         <p:spPr>
           <a:xfrm rot="0">
-            <a:off x="461635" y="3152775"/>
-            <a:ext cx="17364730" cy="3514725"/>
+            <a:off x="461635" y="3609975"/>
+            <a:ext cx="17364730" cy="3057525"/>
           </a:xfrm>
           <a:prstGeom prst="rect">
             <a:avLst/>
@@ -8410,10 +8406,10 @@
                 <a:solidFill>
                   <a:srgbClr val="000000"/>
                 </a:solidFill>
-                <a:latin typeface="Jua"/>
-                <a:ea typeface="Jua"/>
-                <a:cs typeface="Jua"/>
-                <a:sym typeface="Jua"/>
+                <a:latin typeface="무궁화 고딕"/>
+                <a:ea typeface="무궁화 고딕"/>
+                <a:cs typeface="무궁화 고딕"/>
+                <a:sym typeface="무궁화 고딕"/>
               </a:rPr>
               <a:t>ㄷㅅㄱ</a:t>
             </a:r>
@@ -8510,8 +8506,8 @@
         </p:nvSpPr>
         <p:spPr>
           <a:xfrm rot="0">
-            <a:off x="461635" y="3152775"/>
-            <a:ext cx="17364730" cy="3514725"/>
+            <a:off x="461635" y="3609975"/>
+            <a:ext cx="17364730" cy="3057525"/>
           </a:xfrm>
           <a:prstGeom prst="rect">
             <a:avLst/>
@@ -8533,10 +8529,10 @@
                 <a:solidFill>
                   <a:srgbClr val="000000"/>
                 </a:solidFill>
-                <a:latin typeface="Jua"/>
-                <a:ea typeface="Jua"/>
-                <a:cs typeface="Jua"/>
-                <a:sym typeface="Jua"/>
+                <a:latin typeface="무궁화 고딕"/>
+                <a:ea typeface="무궁화 고딕"/>
+                <a:cs typeface="무궁화 고딕"/>
+                <a:sym typeface="무궁화 고딕"/>
               </a:rPr>
               <a:t>ㄷㅅㄱ</a:t>
             </a:r>
@@ -8551,8 +8547,8 @@
         </p:nvSpPr>
         <p:spPr>
           <a:xfrm rot="0">
-            <a:off x="461635" y="6533441"/>
-            <a:ext cx="17364730" cy="1952625"/>
+            <a:off x="461635" y="6800141"/>
+            <a:ext cx="17364730" cy="1685925"/>
           </a:xfrm>
           <a:prstGeom prst="rect">
             <a:avLst/>
@@ -8574,10 +8570,10 @@
                 <a:solidFill>
                   <a:srgbClr val="000000"/>
                 </a:solidFill>
-                <a:latin typeface="Jua"/>
-                <a:ea typeface="Jua"/>
-                <a:cs typeface="Jua"/>
-                <a:sym typeface="Jua"/>
+                <a:latin typeface="무궁화 고딕"/>
+                <a:ea typeface="무궁화 고딕"/>
+                <a:cs typeface="무궁화 고딕"/>
+                <a:sym typeface="무궁화 고딕"/>
               </a:rPr>
               <a:t>Hint : 책이 많아요</a:t>
             </a:r>
@@ -8674,8 +8670,8 @@
         </p:nvSpPr>
         <p:spPr>
           <a:xfrm rot="0">
-            <a:off x="461635" y="3152775"/>
-            <a:ext cx="17364730" cy="3514725"/>
+            <a:off x="461635" y="3609975"/>
+            <a:ext cx="17364730" cy="3057525"/>
           </a:xfrm>
           <a:prstGeom prst="rect">
             <a:avLst/>
@@ -8697,10 +8693,10 @@
                 <a:solidFill>
                   <a:srgbClr val="000000"/>
                 </a:solidFill>
-                <a:latin typeface="Jua"/>
-                <a:ea typeface="Jua"/>
-                <a:cs typeface="Jua"/>
-                <a:sym typeface="Jua"/>
+                <a:latin typeface="무궁화 고딕"/>
+                <a:ea typeface="무궁화 고딕"/>
+                <a:cs typeface="무궁화 고딕"/>
+                <a:sym typeface="무궁화 고딕"/>
               </a:rPr>
               <a:t>도서관</a:t>
             </a:r>
@@ -8797,8 +8793,8 @@
         </p:nvSpPr>
         <p:spPr>
           <a:xfrm rot="0">
-            <a:off x="461635" y="3152775"/>
-            <a:ext cx="17364730" cy="3514725"/>
+            <a:off x="461635" y="3609975"/>
+            <a:ext cx="17364730" cy="3057525"/>
           </a:xfrm>
           <a:prstGeom prst="rect">
             <a:avLst/>
@@ -8820,10 +8816,10 @@
                 <a:solidFill>
                   <a:srgbClr val="000000"/>
                 </a:solidFill>
-                <a:latin typeface="Jua"/>
-                <a:ea typeface="Jua"/>
-                <a:cs typeface="Jua"/>
-                <a:sym typeface="Jua"/>
+                <a:latin typeface="무궁화 고딕"/>
+                <a:ea typeface="무궁화 고딕"/>
+                <a:cs typeface="무궁화 고딕"/>
+                <a:sym typeface="무궁화 고딕"/>
               </a:rPr>
               <a:t>ㅍㅇㅈ</a:t>
             </a:r>
@@ -8920,8 +8916,8 @@
         </p:nvSpPr>
         <p:spPr>
           <a:xfrm rot="0">
-            <a:off x="461635" y="3152775"/>
-            <a:ext cx="17364730" cy="3514725"/>
+            <a:off x="461635" y="3609975"/>
+            <a:ext cx="17364730" cy="3057525"/>
           </a:xfrm>
           <a:prstGeom prst="rect">
             <a:avLst/>
@@ -8943,10 +8939,10 @@
                 <a:solidFill>
                   <a:srgbClr val="000000"/>
                 </a:solidFill>
-                <a:latin typeface="Jua"/>
-                <a:ea typeface="Jua"/>
-                <a:cs typeface="Jua"/>
-                <a:sym typeface="Jua"/>
+                <a:latin typeface="무궁화 고딕"/>
+                <a:ea typeface="무궁화 고딕"/>
+                <a:cs typeface="무궁화 고딕"/>
+                <a:sym typeface="무궁화 고딕"/>
               </a:rPr>
               <a:t>ㅍㅇㅈ</a:t>
             </a:r>
@@ -8961,8 +8957,8 @@
         </p:nvSpPr>
         <p:spPr>
           <a:xfrm rot="0">
-            <a:off x="461635" y="6533441"/>
-            <a:ext cx="17364730" cy="1952625"/>
+            <a:off x="461635" y="6800141"/>
+            <a:ext cx="17364730" cy="1685925"/>
           </a:xfrm>
           <a:prstGeom prst="rect">
             <a:avLst/>
@@ -8984,10 +8980,10 @@
                 <a:solidFill>
                   <a:srgbClr val="000000"/>
                 </a:solidFill>
-                <a:latin typeface="Jua"/>
-                <a:ea typeface="Jua"/>
-                <a:cs typeface="Jua"/>
-                <a:sym typeface="Jua"/>
+                <a:latin typeface="무궁화 고딕"/>
+                <a:ea typeface="무궁화 고딕"/>
+                <a:cs typeface="무궁화 고딕"/>
+                <a:sym typeface="무궁화 고딕"/>
               </a:rPr>
               <a:t>Hint : 24시간</a:t>
             </a:r>
@@ -9084,8 +9080,8 @@
         </p:nvSpPr>
         <p:spPr>
           <a:xfrm rot="0">
-            <a:off x="461635" y="3152775"/>
-            <a:ext cx="17364730" cy="3514725"/>
+            <a:off x="461635" y="3609975"/>
+            <a:ext cx="17364730" cy="3057525"/>
           </a:xfrm>
           <a:prstGeom prst="rect">
             <a:avLst/>
@@ -9107,10 +9103,10 @@
                 <a:solidFill>
                   <a:srgbClr val="000000"/>
                 </a:solidFill>
-                <a:latin typeface="Jua"/>
-                <a:ea typeface="Jua"/>
-                <a:cs typeface="Jua"/>
-                <a:sym typeface="Jua"/>
+                <a:latin typeface="무궁화 고딕"/>
+                <a:ea typeface="무궁화 고딕"/>
+                <a:cs typeface="무궁화 고딕"/>
+                <a:sym typeface="무궁화 고딕"/>
               </a:rPr>
               <a:t>편의점</a:t>
             </a:r>
@@ -9207,8 +9203,8 @@
         </p:nvSpPr>
         <p:spPr>
           <a:xfrm rot="0">
-            <a:off x="461635" y="3152775"/>
-            <a:ext cx="17364730" cy="3514725"/>
+            <a:off x="461635" y="3609975"/>
+            <a:ext cx="17364730" cy="3057525"/>
           </a:xfrm>
           <a:prstGeom prst="rect">
             <a:avLst/>
@@ -9230,10 +9226,10 @@
                 <a:solidFill>
                   <a:srgbClr val="000000"/>
                 </a:solidFill>
-                <a:latin typeface="Jua"/>
-                <a:ea typeface="Jua"/>
-                <a:cs typeface="Jua"/>
-                <a:sym typeface="Jua"/>
+                <a:latin typeface="무궁화 고딕"/>
+                <a:ea typeface="무궁화 고딕"/>
+                <a:cs typeface="무궁화 고딕"/>
+                <a:sym typeface="무궁화 고딕"/>
               </a:rPr>
               <a:t>ㅊㅁㄷ</a:t>
             </a:r>
@@ -9330,8 +9326,8 @@
         </p:nvSpPr>
         <p:spPr>
           <a:xfrm rot="0">
-            <a:off x="461635" y="3152775"/>
-            <a:ext cx="17364730" cy="3514725"/>
+            <a:off x="461635" y="3609975"/>
+            <a:ext cx="17364730" cy="3057525"/>
           </a:xfrm>
           <a:prstGeom prst="rect">
             <a:avLst/>
@@ -9353,10 +9349,10 @@
                 <a:solidFill>
                   <a:srgbClr val="000000"/>
                 </a:solidFill>
-                <a:latin typeface="Jua"/>
-                <a:ea typeface="Jua"/>
-                <a:cs typeface="Jua"/>
-                <a:sym typeface="Jua"/>
+                <a:latin typeface="무궁화 고딕"/>
+                <a:ea typeface="무궁화 고딕"/>
+                <a:cs typeface="무궁화 고딕"/>
+                <a:sym typeface="무궁화 고딕"/>
               </a:rPr>
               <a:t>ㅊㅁㄷ</a:t>
             </a:r>
@@ -9371,8 +9367,8 @@
         </p:nvSpPr>
         <p:spPr>
           <a:xfrm rot="0">
-            <a:off x="461635" y="6533441"/>
-            <a:ext cx="17364730" cy="1952625"/>
+            <a:off x="461635" y="6800141"/>
+            <a:ext cx="17364730" cy="1685925"/>
           </a:xfrm>
           <a:prstGeom prst="rect">
             <a:avLst/>
@@ -9394,10 +9390,10 @@
                 <a:solidFill>
                   <a:srgbClr val="000000"/>
                 </a:solidFill>
-                <a:latin typeface="Jua"/>
-                <a:ea typeface="Jua"/>
-                <a:cs typeface="Jua"/>
-                <a:sym typeface="Jua"/>
+                <a:latin typeface="무궁화 고딕"/>
+                <a:ea typeface="무궁화 고딕"/>
+                <a:cs typeface="무궁화 고딕"/>
+                <a:sym typeface="무궁화 고딕"/>
               </a:rPr>
               <a:t>Hint : 별을 관측해요</a:t>
             </a:r>
@@ -9494,8 +9490,8 @@
         </p:nvSpPr>
         <p:spPr>
           <a:xfrm rot="0">
-            <a:off x="461635" y="3152775"/>
-            <a:ext cx="17364730" cy="3514725"/>
+            <a:off x="461635" y="3609975"/>
+            <a:ext cx="17364730" cy="3057525"/>
           </a:xfrm>
           <a:prstGeom prst="rect">
             <a:avLst/>
@@ -9517,10 +9513,10 @@
                 <a:solidFill>
                   <a:srgbClr val="000000"/>
                 </a:solidFill>
-                <a:latin typeface="Jua"/>
-                <a:ea typeface="Jua"/>
-                <a:cs typeface="Jua"/>
-                <a:sym typeface="Jua"/>
+                <a:latin typeface="무궁화 고딕"/>
+                <a:ea typeface="무궁화 고딕"/>
+                <a:cs typeface="무궁화 고딕"/>
+                <a:sym typeface="무궁화 고딕"/>
               </a:rPr>
               <a:t>천문대</a:t>
             </a:r>
@@ -9617,8 +9613,8 @@
         </p:nvSpPr>
         <p:spPr>
           <a:xfrm rot="0">
-            <a:off x="461635" y="3895725"/>
-            <a:ext cx="17364730" cy="2200275"/>
+            <a:off x="461635" y="4181475"/>
+            <a:ext cx="17364730" cy="1914525"/>
           </a:xfrm>
           <a:prstGeom prst="rect">
             <a:avLst/>
@@ -9640,10 +9636,10 @@
                 <a:solidFill>
                   <a:srgbClr val="000000"/>
                 </a:solidFill>
-                <a:latin typeface="Jua"/>
-                <a:ea typeface="Jua"/>
-                <a:cs typeface="Jua"/>
-                <a:sym typeface="Jua"/>
+                <a:latin typeface="무궁화 고딕"/>
+                <a:ea typeface="무궁화 고딕"/>
+                <a:cs typeface="무궁화 고딕"/>
+                <a:sym typeface="무궁화 고딕"/>
               </a:rPr>
               <a:t>카테고리 : 🍔 음식 🍔</a:t>
             </a:r>
@@ -9740,8 +9736,8 @@
         </p:nvSpPr>
         <p:spPr>
           <a:xfrm rot="0">
-            <a:off x="461635" y="3152775"/>
-            <a:ext cx="17364730" cy="3514725"/>
+            <a:off x="461635" y="3609975"/>
+            <a:ext cx="17364730" cy="3057525"/>
           </a:xfrm>
           <a:prstGeom prst="rect">
             <a:avLst/>
@@ -9763,10 +9759,10 @@
                 <a:solidFill>
                   <a:srgbClr val="000000"/>
                 </a:solidFill>
-                <a:latin typeface="Jua"/>
-                <a:ea typeface="Jua"/>
-                <a:cs typeface="Jua"/>
-                <a:sym typeface="Jua"/>
+                <a:latin typeface="무궁화 고딕"/>
+                <a:ea typeface="무궁화 고딕"/>
+                <a:cs typeface="무궁화 고딕"/>
+                <a:sym typeface="무궁화 고딕"/>
               </a:rPr>
               <a:t>ㄱㅎㅇㅅㄷ</a:t>
             </a:r>
@@ -9863,8 +9859,8 @@
         </p:nvSpPr>
         <p:spPr>
           <a:xfrm rot="0">
-            <a:off x="461635" y="6533441"/>
-            <a:ext cx="17364730" cy="1952625"/>
+            <a:off x="461635" y="6800141"/>
+            <a:ext cx="17364730" cy="1685925"/>
           </a:xfrm>
           <a:prstGeom prst="rect">
             <a:avLst/>
@@ -9886,10 +9882,10 @@
                 <a:solidFill>
                   <a:srgbClr val="000000"/>
                 </a:solidFill>
-                <a:latin typeface="Jua"/>
-                <a:ea typeface="Jua"/>
-                <a:cs typeface="Jua"/>
-                <a:sym typeface="Jua"/>
+                <a:latin typeface="무궁화 고딕"/>
+                <a:ea typeface="무궁화 고딕"/>
+                <a:cs typeface="무궁화 고딕"/>
+                <a:sym typeface="무궁화 고딕"/>
               </a:rPr>
               <a:t>Hint : 법을 만들어요</a:t>
             </a:r>
@@ -9904,8 +9900,8 @@
         </p:nvSpPr>
         <p:spPr>
           <a:xfrm rot="0">
-            <a:off x="461635" y="3152775"/>
-            <a:ext cx="17364730" cy="3514725"/>
+            <a:off x="461635" y="3609975"/>
+            <a:ext cx="17364730" cy="3057525"/>
           </a:xfrm>
           <a:prstGeom prst="rect">
             <a:avLst/>
@@ -9927,10 +9923,10 @@
                 <a:solidFill>
                   <a:srgbClr val="000000"/>
                 </a:solidFill>
-                <a:latin typeface="Jua"/>
-                <a:ea typeface="Jua"/>
-                <a:cs typeface="Jua"/>
-                <a:sym typeface="Jua"/>
+                <a:latin typeface="무궁화 고딕"/>
+                <a:ea typeface="무궁화 고딕"/>
+                <a:cs typeface="무궁화 고딕"/>
+                <a:sym typeface="무궁화 고딕"/>
               </a:rPr>
               <a:t>ㄱㅎㅇㅅㄷ</a:t>
             </a:r>
@@ -10027,8 +10023,8 @@
         </p:nvSpPr>
         <p:spPr>
           <a:xfrm rot="0">
-            <a:off x="461635" y="3152775"/>
-            <a:ext cx="17364730" cy="3514725"/>
+            <a:off x="461635" y="3609975"/>
+            <a:ext cx="17364730" cy="3057525"/>
           </a:xfrm>
           <a:prstGeom prst="rect">
             <a:avLst/>
@@ -10050,10 +10046,10 @@
                 <a:solidFill>
                   <a:srgbClr val="000000"/>
                 </a:solidFill>
-                <a:latin typeface="Jua"/>
-                <a:ea typeface="Jua"/>
-                <a:cs typeface="Jua"/>
-                <a:sym typeface="Jua"/>
+                <a:latin typeface="무궁화 고딕"/>
+                <a:ea typeface="무궁화 고딕"/>
+                <a:cs typeface="무궁화 고딕"/>
+                <a:sym typeface="무궁화 고딕"/>
               </a:rPr>
               <a:t>국회의사당</a:t>
             </a:r>
@@ -10150,8 +10146,8 @@
         </p:nvSpPr>
         <p:spPr>
           <a:xfrm rot="0">
-            <a:off x="461635" y="3895725"/>
-            <a:ext cx="17364730" cy="2200275"/>
+            <a:off x="461635" y="4181475"/>
+            <a:ext cx="17364730" cy="1914525"/>
           </a:xfrm>
           <a:prstGeom prst="rect">
             <a:avLst/>
@@ -10173,10 +10169,10 @@
                 <a:solidFill>
                   <a:srgbClr val="000000"/>
                 </a:solidFill>
-                <a:latin typeface="Jua"/>
-                <a:ea typeface="Jua"/>
-                <a:cs typeface="Jua"/>
-                <a:sym typeface="Jua"/>
+                <a:latin typeface="무궁화 고딕"/>
+                <a:ea typeface="무궁화 고딕"/>
+                <a:cs typeface="무궁화 고딕"/>
+                <a:sym typeface="무궁화 고딕"/>
               </a:rPr>
               <a:t>카테고리 : 👤 인물 👤</a:t>
             </a:r>
@@ -10273,8 +10269,8 @@
         </p:nvSpPr>
         <p:spPr>
           <a:xfrm rot="0">
-            <a:off x="461635" y="3152775"/>
-            <a:ext cx="17364730" cy="3514725"/>
+            <a:off x="461635" y="3609975"/>
+            <a:ext cx="17364730" cy="3057525"/>
           </a:xfrm>
           <a:prstGeom prst="rect">
             <a:avLst/>
@@ -10296,10 +10292,10 @@
                 <a:solidFill>
                   <a:srgbClr val="000000"/>
                 </a:solidFill>
-                <a:latin typeface="Jua"/>
-                <a:ea typeface="Jua"/>
-                <a:cs typeface="Jua"/>
-                <a:sym typeface="Jua"/>
+                <a:latin typeface="무궁화 고딕"/>
+                <a:ea typeface="무궁화 고딕"/>
+                <a:cs typeface="무궁화 고딕"/>
+                <a:sym typeface="무궁화 고딕"/>
               </a:rPr>
               <a:t>ㅇㅅㅅ</a:t>
             </a:r>
@@ -10396,8 +10392,8 @@
         </p:nvSpPr>
         <p:spPr>
           <a:xfrm rot="0">
-            <a:off x="461635" y="3152775"/>
-            <a:ext cx="17364730" cy="3514725"/>
+            <a:off x="461635" y="3609975"/>
+            <a:ext cx="17364730" cy="3057525"/>
           </a:xfrm>
           <a:prstGeom prst="rect">
             <a:avLst/>
@@ -10419,10 +10415,10 @@
                 <a:solidFill>
                   <a:srgbClr val="000000"/>
                 </a:solidFill>
-                <a:latin typeface="Jua"/>
-                <a:ea typeface="Jua"/>
-                <a:cs typeface="Jua"/>
-                <a:sym typeface="Jua"/>
+                <a:latin typeface="무궁화 고딕"/>
+                <a:ea typeface="무궁화 고딕"/>
+                <a:cs typeface="무궁화 고딕"/>
+                <a:sym typeface="무궁화 고딕"/>
               </a:rPr>
               <a:t>ㅇㅅㅅ</a:t>
             </a:r>
@@ -10437,8 +10433,8 @@
         </p:nvSpPr>
         <p:spPr>
           <a:xfrm rot="0">
-            <a:off x="461635" y="6533441"/>
-            <a:ext cx="17364730" cy="1952625"/>
+            <a:off x="461635" y="6800141"/>
+            <a:ext cx="17364730" cy="1685925"/>
           </a:xfrm>
           <a:prstGeom prst="rect">
             <a:avLst/>
@@ -10460,10 +10456,10 @@
                 <a:solidFill>
                   <a:srgbClr val="000000"/>
                 </a:solidFill>
-                <a:latin typeface="Jua"/>
-                <a:ea typeface="Jua"/>
-                <a:cs typeface="Jua"/>
-                <a:sym typeface="Jua"/>
+                <a:latin typeface="무궁화 고딕"/>
+                <a:ea typeface="무궁화 고딕"/>
+                <a:cs typeface="무궁화 고딕"/>
+                <a:sym typeface="무궁화 고딕"/>
               </a:rPr>
               <a:t>Hint : 거북선</a:t>
             </a:r>
@@ -10560,8 +10556,8 @@
         </p:nvSpPr>
         <p:spPr>
           <a:xfrm rot="0">
-            <a:off x="461635" y="3152775"/>
-            <a:ext cx="17364730" cy="3514725"/>
+            <a:off x="461635" y="3609975"/>
+            <a:ext cx="17364730" cy="3057525"/>
           </a:xfrm>
           <a:prstGeom prst="rect">
             <a:avLst/>
@@ -10583,10 +10579,10 @@
                 <a:solidFill>
                   <a:srgbClr val="000000"/>
                 </a:solidFill>
-                <a:latin typeface="Jua"/>
-                <a:ea typeface="Jua"/>
-                <a:cs typeface="Jua"/>
-                <a:sym typeface="Jua"/>
+                <a:latin typeface="무궁화 고딕"/>
+                <a:ea typeface="무궁화 고딕"/>
+                <a:cs typeface="무궁화 고딕"/>
+                <a:sym typeface="무궁화 고딕"/>
               </a:rPr>
               <a:t>이순신</a:t>
             </a:r>
@@ -10683,8 +10679,8 @@
         </p:nvSpPr>
         <p:spPr>
           <a:xfrm rot="0">
-            <a:off x="461635" y="3152775"/>
-            <a:ext cx="17364730" cy="3514725"/>
+            <a:off x="461635" y="3609975"/>
+            <a:ext cx="17364730" cy="3057525"/>
           </a:xfrm>
           <a:prstGeom prst="rect">
             <a:avLst/>
@@ -10706,10 +10702,10 @@
                 <a:solidFill>
                   <a:srgbClr val="000000"/>
                 </a:solidFill>
-                <a:latin typeface="Jua"/>
-                <a:ea typeface="Jua"/>
-                <a:cs typeface="Jua"/>
-                <a:sym typeface="Jua"/>
+                <a:latin typeface="무궁화 고딕"/>
+                <a:ea typeface="무궁화 고딕"/>
+                <a:cs typeface="무궁화 고딕"/>
+                <a:sym typeface="무궁화 고딕"/>
               </a:rPr>
               <a:t>ㅅㅈㄷㅇ</a:t>
             </a:r>
@@ -10806,8 +10802,8 @@
         </p:nvSpPr>
         <p:spPr>
           <a:xfrm rot="0">
-            <a:off x="461635" y="3152775"/>
-            <a:ext cx="17364730" cy="3514725"/>
+            <a:off x="461635" y="3609975"/>
+            <a:ext cx="17364730" cy="3057525"/>
           </a:xfrm>
           <a:prstGeom prst="rect">
             <a:avLst/>
@@ -10829,10 +10825,10 @@
                 <a:solidFill>
                   <a:srgbClr val="000000"/>
                 </a:solidFill>
-                <a:latin typeface="Jua"/>
-                <a:ea typeface="Jua"/>
-                <a:cs typeface="Jua"/>
-                <a:sym typeface="Jua"/>
+                <a:latin typeface="무궁화 고딕"/>
+                <a:ea typeface="무궁화 고딕"/>
+                <a:cs typeface="무궁화 고딕"/>
+                <a:sym typeface="무궁화 고딕"/>
               </a:rPr>
               <a:t>ㅅㅈㄷㅇ</a:t>
             </a:r>
@@ -10847,8 +10843,8 @@
         </p:nvSpPr>
         <p:spPr>
           <a:xfrm rot="0">
-            <a:off x="461635" y="6533441"/>
-            <a:ext cx="17364730" cy="1952625"/>
+            <a:off x="461635" y="6800141"/>
+            <a:ext cx="17364730" cy="1685925"/>
           </a:xfrm>
           <a:prstGeom prst="rect">
             <a:avLst/>
@@ -10870,10 +10866,10 @@
                 <a:solidFill>
                   <a:srgbClr val="000000"/>
                 </a:solidFill>
-                <a:latin typeface="Jua"/>
-                <a:ea typeface="Jua"/>
-                <a:cs typeface="Jua"/>
-                <a:sym typeface="Jua"/>
+                <a:latin typeface="무궁화 고딕"/>
+                <a:ea typeface="무궁화 고딕"/>
+                <a:cs typeface="무궁화 고딕"/>
+                <a:sym typeface="무궁화 고딕"/>
               </a:rPr>
               <a:t>Hint : 훈민정음</a:t>
             </a:r>
@@ -10970,8 +10966,8 @@
         </p:nvSpPr>
         <p:spPr>
           <a:xfrm rot="0">
-            <a:off x="461635" y="3152775"/>
-            <a:ext cx="17364730" cy="3514725"/>
+            <a:off x="461635" y="3609975"/>
+            <a:ext cx="17364730" cy="3057525"/>
           </a:xfrm>
           <a:prstGeom prst="rect">
             <a:avLst/>
@@ -10993,10 +10989,10 @@
                 <a:solidFill>
                   <a:srgbClr val="000000"/>
                 </a:solidFill>
-                <a:latin typeface="Jua"/>
-                <a:ea typeface="Jua"/>
-                <a:cs typeface="Jua"/>
-                <a:sym typeface="Jua"/>
+                <a:latin typeface="무궁화 고딕"/>
+                <a:ea typeface="무궁화 고딕"/>
+                <a:cs typeface="무궁화 고딕"/>
+                <a:sym typeface="무궁화 고딕"/>
               </a:rPr>
               <a:t>세종대왕</a:t>
             </a:r>
@@ -11093,8 +11089,8 @@
         </p:nvSpPr>
         <p:spPr>
           <a:xfrm rot="0">
-            <a:off x="461635" y="3152775"/>
-            <a:ext cx="17364730" cy="3514725"/>
+            <a:off x="461635" y="3609975"/>
+            <a:ext cx="17364730" cy="3057525"/>
           </a:xfrm>
           <a:prstGeom prst="rect">
             <a:avLst/>
@@ -11116,10 +11112,10 @@
                 <a:solidFill>
                   <a:srgbClr val="000000"/>
                 </a:solidFill>
-                <a:latin typeface="Jua"/>
-                <a:ea typeface="Jua"/>
-                <a:cs typeface="Jua"/>
-                <a:sym typeface="Jua"/>
+                <a:latin typeface="무궁화 고딕"/>
+                <a:ea typeface="무궁화 고딕"/>
+                <a:cs typeface="무궁화 고딕"/>
+                <a:sym typeface="무궁화 고딕"/>
               </a:rPr>
               <a:t>ㅂㅇㅃ</a:t>
             </a:r>
@@ -11216,8 +11212,8 @@
         </p:nvSpPr>
         <p:spPr>
           <a:xfrm rot="0">
-            <a:off x="461635" y="3152775"/>
-            <a:ext cx="17364730" cy="3514725"/>
+            <a:off x="461635" y="3609975"/>
+            <a:ext cx="17364730" cy="3057525"/>
           </a:xfrm>
           <a:prstGeom prst="rect">
             <a:avLst/>
@@ -11239,10 +11235,10 @@
                 <a:solidFill>
                   <a:srgbClr val="000000"/>
                 </a:solidFill>
-                <a:latin typeface="Jua"/>
-                <a:ea typeface="Jua"/>
-                <a:cs typeface="Jua"/>
-                <a:sym typeface="Jua"/>
+                <a:latin typeface="무궁화 고딕"/>
+                <a:ea typeface="무궁화 고딕"/>
+                <a:cs typeface="무궁화 고딕"/>
+                <a:sym typeface="무궁화 고딕"/>
               </a:rPr>
               <a:t>ㅇㅈㄱ</a:t>
             </a:r>
@@ -11339,8 +11335,8 @@
         </p:nvSpPr>
         <p:spPr>
           <a:xfrm rot="0">
-            <a:off x="461635" y="3152775"/>
-            <a:ext cx="17364730" cy="3514725"/>
+            <a:off x="461635" y="3609975"/>
+            <a:ext cx="17364730" cy="3057525"/>
           </a:xfrm>
           <a:prstGeom prst="rect">
             <a:avLst/>
@@ -11362,10 +11358,10 @@
                 <a:solidFill>
                   <a:srgbClr val="000000"/>
                 </a:solidFill>
-                <a:latin typeface="Jua"/>
-                <a:ea typeface="Jua"/>
-                <a:cs typeface="Jua"/>
-                <a:sym typeface="Jua"/>
+                <a:latin typeface="무궁화 고딕"/>
+                <a:ea typeface="무궁화 고딕"/>
+                <a:cs typeface="무궁화 고딕"/>
+                <a:sym typeface="무궁화 고딕"/>
               </a:rPr>
               <a:t>ㅇㅈㄱ</a:t>
             </a:r>
@@ -11380,8 +11376,8 @@
         </p:nvSpPr>
         <p:spPr>
           <a:xfrm rot="0">
-            <a:off x="461635" y="6533441"/>
-            <a:ext cx="17364730" cy="1952625"/>
+            <a:off x="461635" y="6800141"/>
+            <a:ext cx="17364730" cy="1685925"/>
           </a:xfrm>
           <a:prstGeom prst="rect">
             <a:avLst/>
@@ -11403,10 +11399,10 @@
                 <a:solidFill>
                   <a:srgbClr val="000000"/>
                 </a:solidFill>
-                <a:latin typeface="Jua"/>
-                <a:ea typeface="Jua"/>
-                <a:cs typeface="Jua"/>
-                <a:sym typeface="Jua"/>
+                <a:latin typeface="무궁화 고딕"/>
+                <a:ea typeface="무궁화 고딕"/>
+                <a:cs typeface="무궁화 고딕"/>
+                <a:sym typeface="무궁화 고딕"/>
               </a:rPr>
               <a:t>Hint : 하얼빈 의사</a:t>
             </a:r>
@@ -11503,8 +11499,8 @@
         </p:nvSpPr>
         <p:spPr>
           <a:xfrm rot="0">
-            <a:off x="461635" y="3152775"/>
-            <a:ext cx="17364730" cy="3514725"/>
+            <a:off x="461635" y="3609975"/>
+            <a:ext cx="17364730" cy="3057525"/>
           </a:xfrm>
           <a:prstGeom prst="rect">
             <a:avLst/>
@@ -11526,10 +11522,10 @@
                 <a:solidFill>
                   <a:srgbClr val="000000"/>
                 </a:solidFill>
-                <a:latin typeface="Jua"/>
-                <a:ea typeface="Jua"/>
-                <a:cs typeface="Jua"/>
-                <a:sym typeface="Jua"/>
+                <a:latin typeface="무궁화 고딕"/>
+                <a:ea typeface="무궁화 고딕"/>
+                <a:cs typeface="무궁화 고딕"/>
+                <a:sym typeface="무궁화 고딕"/>
               </a:rPr>
               <a:t>안중근</a:t>
             </a:r>
@@ -11626,8 +11622,8 @@
         </p:nvSpPr>
         <p:spPr>
           <a:xfrm rot="0">
-            <a:off x="461635" y="3152775"/>
-            <a:ext cx="17364730" cy="3514725"/>
+            <a:off x="461635" y="3609975"/>
+            <a:ext cx="17364730" cy="3057525"/>
           </a:xfrm>
           <a:prstGeom prst="rect">
             <a:avLst/>
@@ -11649,10 +11645,10 @@
                 <a:solidFill>
                   <a:srgbClr val="000000"/>
                 </a:solidFill>
-                <a:latin typeface="Jua"/>
-                <a:ea typeface="Jua"/>
-                <a:cs typeface="Jua"/>
-                <a:sym typeface="Jua"/>
+                <a:latin typeface="무궁화 고딕"/>
+                <a:ea typeface="무궁화 고딕"/>
+                <a:cs typeface="무궁화 고딕"/>
+                <a:sym typeface="무궁화 고딕"/>
               </a:rPr>
               <a:t>ㄱㄱㅌㄷㅇ</a:t>
             </a:r>
@@ -11749,8 +11745,8 @@
         </p:nvSpPr>
         <p:spPr>
           <a:xfrm rot="0">
-            <a:off x="461635" y="3152775"/>
-            <a:ext cx="17364730" cy="3514725"/>
+            <a:off x="461635" y="3609975"/>
+            <a:ext cx="17364730" cy="3057525"/>
           </a:xfrm>
           <a:prstGeom prst="rect">
             <a:avLst/>
@@ -11772,10 +11768,10 @@
                 <a:solidFill>
                   <a:srgbClr val="000000"/>
                 </a:solidFill>
-                <a:latin typeface="Jua"/>
-                <a:ea typeface="Jua"/>
-                <a:cs typeface="Jua"/>
-                <a:sym typeface="Jua"/>
+                <a:latin typeface="무궁화 고딕"/>
+                <a:ea typeface="무궁화 고딕"/>
+                <a:cs typeface="무궁화 고딕"/>
+                <a:sym typeface="무궁화 고딕"/>
               </a:rPr>
               <a:t>ㄱㄱㅌㄷㅇ</a:t>
             </a:r>
@@ -11790,8 +11786,8 @@
         </p:nvSpPr>
         <p:spPr>
           <a:xfrm rot="0">
-            <a:off x="461635" y="6533441"/>
-            <a:ext cx="17364730" cy="1952625"/>
+            <a:off x="461635" y="6800141"/>
+            <a:ext cx="17364730" cy="1685925"/>
           </a:xfrm>
           <a:prstGeom prst="rect">
             <a:avLst/>
@@ -11813,10 +11809,10 @@
                 <a:solidFill>
                   <a:srgbClr val="000000"/>
                 </a:solidFill>
-                <a:latin typeface="Jua"/>
-                <a:ea typeface="Jua"/>
-                <a:cs typeface="Jua"/>
-                <a:sym typeface="Jua"/>
+                <a:latin typeface="무궁화 고딕"/>
+                <a:ea typeface="무궁화 고딕"/>
+                <a:cs typeface="무궁화 고딕"/>
+                <a:sym typeface="무궁화 고딕"/>
               </a:rPr>
               <a:t>Hint : 고구려 왕</a:t>
             </a:r>
@@ -11913,8 +11909,8 @@
         </p:nvSpPr>
         <p:spPr>
           <a:xfrm rot="0">
-            <a:off x="461635" y="3152775"/>
-            <a:ext cx="17364730" cy="3514725"/>
+            <a:off x="461635" y="3609975"/>
+            <a:ext cx="17364730" cy="3057525"/>
           </a:xfrm>
           <a:prstGeom prst="rect">
             <a:avLst/>
@@ -11936,10 +11932,10 @@
                 <a:solidFill>
                   <a:srgbClr val="000000"/>
                 </a:solidFill>
-                <a:latin typeface="Jua"/>
-                <a:ea typeface="Jua"/>
-                <a:cs typeface="Jua"/>
-                <a:sym typeface="Jua"/>
+                <a:latin typeface="무궁화 고딕"/>
+                <a:ea typeface="무궁화 고딕"/>
+                <a:cs typeface="무궁화 고딕"/>
+                <a:sym typeface="무궁화 고딕"/>
               </a:rPr>
               <a:t>광개토대왕</a:t>
             </a:r>
@@ -12036,8 +12032,8 @@
         </p:nvSpPr>
         <p:spPr>
           <a:xfrm rot="0">
-            <a:off x="461635" y="3152775"/>
-            <a:ext cx="17364730" cy="3514725"/>
+            <a:off x="461635" y="3609975"/>
+            <a:ext cx="17364730" cy="3057525"/>
           </a:xfrm>
           <a:prstGeom prst="rect">
             <a:avLst/>
@@ -12059,10 +12055,10 @@
                 <a:solidFill>
                   <a:srgbClr val="000000"/>
                 </a:solidFill>
-                <a:latin typeface="Jua"/>
-                <a:ea typeface="Jua"/>
-                <a:cs typeface="Jua"/>
-                <a:sym typeface="Jua"/>
+                <a:latin typeface="무궁화 고딕"/>
+                <a:ea typeface="무궁화 고딕"/>
+                <a:cs typeface="무궁화 고딕"/>
+                <a:sym typeface="무궁화 고딕"/>
               </a:rPr>
               <a:t>ㅇㅈㅁㄷ</a:t>
             </a:r>
@@ -12159,8 +12155,8 @@
         </p:nvSpPr>
         <p:spPr>
           <a:xfrm rot="0">
-            <a:off x="461635" y="6533441"/>
-            <a:ext cx="17364730" cy="1952625"/>
+            <a:off x="461635" y="6800141"/>
+            <a:ext cx="17364730" cy="1685925"/>
           </a:xfrm>
           <a:prstGeom prst="rect">
             <a:avLst/>
@@ -12182,10 +12178,10 @@
                 <a:solidFill>
                   <a:srgbClr val="000000"/>
                 </a:solidFill>
-                <a:latin typeface="Jua"/>
-                <a:ea typeface="Jua"/>
-                <a:cs typeface="Jua"/>
-                <a:sym typeface="Jua"/>
+                <a:latin typeface="무궁화 고딕"/>
+                <a:ea typeface="무궁화 고딕"/>
+                <a:cs typeface="무궁화 고딕"/>
+                <a:sym typeface="무궁화 고딕"/>
               </a:rPr>
               <a:t>Hint : 살수대첩</a:t>
             </a:r>
@@ -12200,8 +12196,8 @@
         </p:nvSpPr>
         <p:spPr>
           <a:xfrm rot="0">
-            <a:off x="461635" y="3152775"/>
-            <a:ext cx="17364730" cy="3514725"/>
+            <a:off x="461635" y="3609975"/>
+            <a:ext cx="17364730" cy="3057525"/>
           </a:xfrm>
           <a:prstGeom prst="rect">
             <a:avLst/>
@@ -12223,10 +12219,10 @@
                 <a:solidFill>
                   <a:srgbClr val="000000"/>
                 </a:solidFill>
-                <a:latin typeface="Jua"/>
-                <a:ea typeface="Jua"/>
-                <a:cs typeface="Jua"/>
-                <a:sym typeface="Jua"/>
+                <a:latin typeface="무궁화 고딕"/>
+                <a:ea typeface="무궁화 고딕"/>
+                <a:cs typeface="무궁화 고딕"/>
+                <a:sym typeface="무궁화 고딕"/>
               </a:rPr>
               <a:t>ㅇㅈㅁㄷ</a:t>
             </a:r>
@@ -12323,8 +12319,8 @@
         </p:nvSpPr>
         <p:spPr>
           <a:xfrm rot="0">
-            <a:off x="461635" y="3152775"/>
-            <a:ext cx="17364730" cy="3514725"/>
+            <a:off x="461635" y="3609975"/>
+            <a:ext cx="17364730" cy="3057525"/>
           </a:xfrm>
           <a:prstGeom prst="rect">
             <a:avLst/>
@@ -12346,10 +12342,10 @@
                 <a:solidFill>
                   <a:srgbClr val="000000"/>
                 </a:solidFill>
-                <a:latin typeface="Jua"/>
-                <a:ea typeface="Jua"/>
-                <a:cs typeface="Jua"/>
-                <a:sym typeface="Jua"/>
+                <a:latin typeface="무궁화 고딕"/>
+                <a:ea typeface="무궁화 고딕"/>
+                <a:cs typeface="무궁화 고딕"/>
+                <a:sym typeface="무궁화 고딕"/>
               </a:rPr>
               <a:t>을지문덕</a:t>
             </a:r>
@@ -12446,8 +12442,8 @@
         </p:nvSpPr>
         <p:spPr>
           <a:xfrm rot="0">
-            <a:off x="461635" y="3895725"/>
-            <a:ext cx="17364730" cy="2200275"/>
+            <a:off x="461635" y="4205287"/>
+            <a:ext cx="17364730" cy="1866900"/>
           </a:xfrm>
           <a:prstGeom prst="rect">
             <a:avLst/>
@@ -12461,18 +12457,18 @@
           <a:p>
             <a:pPr algn="ctr">
               <a:lnSpc>
-                <a:spcPts val="15000"/>
+                <a:spcPts val="14640"/>
               </a:lnSpc>
             </a:pPr>
             <a:r>
-              <a:rPr lang="en-US" sz="12500">
+              <a:rPr lang="en-US" sz="12200">
                 <a:solidFill>
                   <a:srgbClr val="000000"/>
                 </a:solidFill>
-                <a:latin typeface="Jua"/>
-                <a:ea typeface="Jua"/>
-                <a:cs typeface="Jua"/>
-                <a:sym typeface="Jua"/>
+                <a:latin typeface="무궁화 고딕"/>
+                <a:ea typeface="무궁화 고딕"/>
+                <a:cs typeface="무궁화 고딕"/>
+                <a:sym typeface="무궁화 고딕"/>
               </a:rPr>
               <a:t>카테고리 : 🎄 문화/생활 🎄</a:t>
             </a:r>
@@ -12569,8 +12565,8 @@
         </p:nvSpPr>
         <p:spPr>
           <a:xfrm rot="0">
-            <a:off x="461635" y="3152775"/>
-            <a:ext cx="17364730" cy="3514725"/>
+            <a:off x="461635" y="3609975"/>
+            <a:ext cx="17364730" cy="3057525"/>
           </a:xfrm>
           <a:prstGeom prst="rect">
             <a:avLst/>
@@ -12592,10 +12588,10 @@
                 <a:solidFill>
                   <a:srgbClr val="000000"/>
                 </a:solidFill>
-                <a:latin typeface="Jua"/>
-                <a:ea typeface="Jua"/>
-                <a:cs typeface="Jua"/>
-                <a:sym typeface="Jua"/>
+                <a:latin typeface="무궁화 고딕"/>
+                <a:ea typeface="무궁화 고딕"/>
+                <a:cs typeface="무궁화 고딕"/>
+                <a:sym typeface="무궁화 고딕"/>
               </a:rPr>
               <a:t>ㅂㅇㅃ</a:t>
             </a:r>
@@ -12610,8 +12606,8 @@
         </p:nvSpPr>
         <p:spPr>
           <a:xfrm rot="0">
-            <a:off x="461635" y="6533441"/>
-            <a:ext cx="17364730" cy="1952625"/>
+            <a:off x="461635" y="6800141"/>
+            <a:ext cx="17364730" cy="1685925"/>
           </a:xfrm>
           <a:prstGeom prst="rect">
             <a:avLst/>
@@ -12633,10 +12629,10 @@
                 <a:solidFill>
                   <a:srgbClr val="000000"/>
                 </a:solidFill>
-                <a:latin typeface="Jua"/>
-                <a:ea typeface="Jua"/>
-                <a:cs typeface="Jua"/>
-                <a:sym typeface="Jua"/>
+                <a:latin typeface="무궁화 고딕"/>
+                <a:ea typeface="무궁화 고딕"/>
+                <a:cs typeface="무궁화 고딕"/>
+                <a:sym typeface="무궁화 고딕"/>
               </a:rPr>
               <a:t>Hint : 겨울 간식</a:t>
             </a:r>
@@ -12733,8 +12729,8 @@
         </p:nvSpPr>
         <p:spPr>
           <a:xfrm rot="0">
-            <a:off x="461635" y="3152775"/>
-            <a:ext cx="17364730" cy="3514725"/>
+            <a:off x="461635" y="3609975"/>
+            <a:ext cx="17364730" cy="3057525"/>
           </a:xfrm>
           <a:prstGeom prst="rect">
             <a:avLst/>
@@ -12756,10 +12752,10 @@
                 <a:solidFill>
                   <a:srgbClr val="000000"/>
                 </a:solidFill>
-                <a:latin typeface="Jua"/>
-                <a:ea typeface="Jua"/>
-                <a:cs typeface="Jua"/>
-                <a:sym typeface="Jua"/>
+                <a:latin typeface="무궁화 고딕"/>
+                <a:ea typeface="무궁화 고딕"/>
+                <a:cs typeface="무궁화 고딕"/>
+                <a:sym typeface="무궁화 고딕"/>
               </a:rPr>
               <a:t>ㅇㅎ</a:t>
             </a:r>
@@ -12856,8 +12852,8 @@
         </p:nvSpPr>
         <p:spPr>
           <a:xfrm rot="0">
-            <a:off x="461635" y="3152775"/>
-            <a:ext cx="17364730" cy="3514725"/>
+            <a:off x="461635" y="3609975"/>
+            <a:ext cx="17364730" cy="3057525"/>
           </a:xfrm>
           <a:prstGeom prst="rect">
             <a:avLst/>
@@ -12879,10 +12875,10 @@
                 <a:solidFill>
                   <a:srgbClr val="000000"/>
                 </a:solidFill>
-                <a:latin typeface="Jua"/>
-                <a:ea typeface="Jua"/>
-                <a:cs typeface="Jua"/>
-                <a:sym typeface="Jua"/>
+                <a:latin typeface="무궁화 고딕"/>
+                <a:ea typeface="무궁화 고딕"/>
+                <a:cs typeface="무궁화 고딕"/>
+                <a:sym typeface="무궁화 고딕"/>
               </a:rPr>
               <a:t>ㅇㅎ</a:t>
             </a:r>
@@ -12897,8 +12893,8 @@
         </p:nvSpPr>
         <p:spPr>
           <a:xfrm rot="0">
-            <a:off x="461635" y="6533441"/>
-            <a:ext cx="17364730" cy="1952625"/>
+            <a:off x="461635" y="6800141"/>
+            <a:ext cx="17364730" cy="1685925"/>
           </a:xfrm>
           <a:prstGeom prst="rect">
             <a:avLst/>
@@ -12920,10 +12916,10 @@
                 <a:solidFill>
                   <a:srgbClr val="000000"/>
                 </a:solidFill>
-                <a:latin typeface="Jua"/>
-                <a:ea typeface="Jua"/>
-                <a:cs typeface="Jua"/>
-                <a:sym typeface="Jua"/>
+                <a:latin typeface="무궁화 고딕"/>
+                <a:ea typeface="무궁화 고딕"/>
+                <a:cs typeface="무궁화 고딕"/>
+                <a:sym typeface="무궁화 고딕"/>
               </a:rPr>
               <a:t>Hint : 극장에서 봐요</a:t>
             </a:r>
@@ -13020,8 +13016,8 @@
         </p:nvSpPr>
         <p:spPr>
           <a:xfrm rot="0">
-            <a:off x="461635" y="3152775"/>
-            <a:ext cx="17364730" cy="3514725"/>
+            <a:off x="461635" y="3609975"/>
+            <a:ext cx="17364730" cy="3057525"/>
           </a:xfrm>
           <a:prstGeom prst="rect">
             <a:avLst/>
@@ -13043,10 +13039,10 @@
                 <a:solidFill>
                   <a:srgbClr val="000000"/>
                 </a:solidFill>
-                <a:latin typeface="Jua"/>
-                <a:ea typeface="Jua"/>
-                <a:cs typeface="Jua"/>
-                <a:sym typeface="Jua"/>
+                <a:latin typeface="무궁화 고딕"/>
+                <a:ea typeface="무궁화 고딕"/>
+                <a:cs typeface="무궁화 고딕"/>
+                <a:sym typeface="무궁화 고딕"/>
               </a:rPr>
               <a:t>영화</a:t>
             </a:r>
@@ -13143,8 +13139,8 @@
         </p:nvSpPr>
         <p:spPr>
           <a:xfrm rot="0">
-            <a:off x="461635" y="3152775"/>
-            <a:ext cx="17364730" cy="3514725"/>
+            <a:off x="461635" y="3609975"/>
+            <a:ext cx="17364730" cy="3057525"/>
           </a:xfrm>
           <a:prstGeom prst="rect">
             <a:avLst/>
@@ -13166,10 +13162,10 @@
                 <a:solidFill>
                   <a:srgbClr val="000000"/>
                 </a:solidFill>
-                <a:latin typeface="Jua"/>
-                <a:ea typeface="Jua"/>
-                <a:cs typeface="Jua"/>
-                <a:sym typeface="Jua"/>
+                <a:latin typeface="무궁화 고딕"/>
+                <a:ea typeface="무궁화 고딕"/>
+                <a:cs typeface="무궁화 고딕"/>
+                <a:sym typeface="무궁화 고딕"/>
               </a:rPr>
               <a:t>ㅈㅈㄱ</a:t>
             </a:r>
@@ -13266,8 +13262,8 @@
         </p:nvSpPr>
         <p:spPr>
           <a:xfrm rot="0">
-            <a:off x="461635" y="3152775"/>
-            <a:ext cx="17364730" cy="3514725"/>
+            <a:off x="461635" y="3609975"/>
+            <a:ext cx="17364730" cy="3057525"/>
           </a:xfrm>
           <a:prstGeom prst="rect">
             <a:avLst/>
@@ -13289,10 +13285,10 @@
                 <a:solidFill>
                   <a:srgbClr val="000000"/>
                 </a:solidFill>
-                <a:latin typeface="Jua"/>
-                <a:ea typeface="Jua"/>
-                <a:cs typeface="Jua"/>
-                <a:sym typeface="Jua"/>
+                <a:latin typeface="무궁화 고딕"/>
+                <a:ea typeface="무궁화 고딕"/>
+                <a:cs typeface="무궁화 고딕"/>
+                <a:sym typeface="무궁화 고딕"/>
               </a:rPr>
               <a:t>ㅈㅈㄱ</a:t>
             </a:r>
@@ -13307,8 +13303,8 @@
         </p:nvSpPr>
         <p:spPr>
           <a:xfrm rot="0">
-            <a:off x="461635" y="6533441"/>
-            <a:ext cx="17364730" cy="1952625"/>
+            <a:off x="461635" y="6800141"/>
+            <a:ext cx="17364730" cy="1685925"/>
           </a:xfrm>
           <a:prstGeom prst="rect">
             <a:avLst/>
@@ -13330,10 +13326,10 @@
                 <a:solidFill>
                   <a:srgbClr val="000000"/>
                 </a:solidFill>
-                <a:latin typeface="Jua"/>
-                <a:ea typeface="Jua"/>
-                <a:cs typeface="Jua"/>
-                <a:sym typeface="Jua"/>
+                <a:latin typeface="무궁화 고딕"/>
+                <a:ea typeface="무궁화 고딕"/>
+                <a:cs typeface="무궁화 고딕"/>
+                <a:sym typeface="무궁화 고딕"/>
               </a:rPr>
               <a:t>Hint : 두 바퀴로 가요</a:t>
             </a:r>
@@ -13430,8 +13426,8 @@
         </p:nvSpPr>
         <p:spPr>
           <a:xfrm rot="0">
-            <a:off x="461635" y="3152775"/>
-            <a:ext cx="17364730" cy="3514725"/>
+            <a:off x="461635" y="3609975"/>
+            <a:ext cx="17364730" cy="3057525"/>
           </a:xfrm>
           <a:prstGeom prst="rect">
             <a:avLst/>
@@ -13453,10 +13449,10 @@
                 <a:solidFill>
                   <a:srgbClr val="000000"/>
                 </a:solidFill>
-                <a:latin typeface="Jua"/>
-                <a:ea typeface="Jua"/>
-                <a:cs typeface="Jua"/>
-                <a:sym typeface="Jua"/>
+                <a:latin typeface="무궁화 고딕"/>
+                <a:ea typeface="무궁화 고딕"/>
+                <a:cs typeface="무궁화 고딕"/>
+                <a:sym typeface="무궁화 고딕"/>
               </a:rPr>
               <a:t>자전거</a:t>
             </a:r>
@@ -13553,8 +13549,8 @@
         </p:nvSpPr>
         <p:spPr>
           <a:xfrm rot="0">
-            <a:off x="461635" y="3152775"/>
-            <a:ext cx="17364730" cy="3514725"/>
+            <a:off x="461635" y="3609975"/>
+            <a:ext cx="17364730" cy="3057525"/>
           </a:xfrm>
           <a:prstGeom prst="rect">
             <a:avLst/>
@@ -13576,10 +13572,10 @@
                 <a:solidFill>
                   <a:srgbClr val="000000"/>
                 </a:solidFill>
-                <a:latin typeface="Jua"/>
-                <a:ea typeface="Jua"/>
-                <a:cs typeface="Jua"/>
-                <a:sym typeface="Jua"/>
+                <a:latin typeface="무궁화 고딕"/>
+                <a:ea typeface="무궁화 고딕"/>
+                <a:cs typeface="무궁화 고딕"/>
+                <a:sym typeface="무궁화 고딕"/>
               </a:rPr>
               <a:t>ㅋㅍㅌ</a:t>
             </a:r>
@@ -13676,8 +13672,8 @@
         </p:nvSpPr>
         <p:spPr>
           <a:xfrm rot="0">
-            <a:off x="461635" y="3152775"/>
-            <a:ext cx="17364730" cy="3514725"/>
+            <a:off x="461635" y="3609975"/>
+            <a:ext cx="17364730" cy="3057525"/>
           </a:xfrm>
           <a:prstGeom prst="rect">
             <a:avLst/>
@@ -13699,10 +13695,10 @@
                 <a:solidFill>
                   <a:srgbClr val="000000"/>
                 </a:solidFill>
-                <a:latin typeface="Jua"/>
-                <a:ea typeface="Jua"/>
-                <a:cs typeface="Jua"/>
-                <a:sym typeface="Jua"/>
+                <a:latin typeface="무궁화 고딕"/>
+                <a:ea typeface="무궁화 고딕"/>
+                <a:cs typeface="무궁화 고딕"/>
+                <a:sym typeface="무궁화 고딕"/>
               </a:rPr>
               <a:t>ㅋㅍㅌ</a:t>
             </a:r>
@@ -13717,8 +13713,8 @@
         </p:nvSpPr>
         <p:spPr>
           <a:xfrm rot="0">
-            <a:off x="461635" y="6533441"/>
-            <a:ext cx="17364730" cy="1952625"/>
+            <a:off x="461635" y="6800141"/>
+            <a:ext cx="17364730" cy="1685925"/>
           </a:xfrm>
           <a:prstGeom prst="rect">
             <a:avLst/>
@@ -13740,10 +13736,10 @@
                 <a:solidFill>
                   <a:srgbClr val="000000"/>
                 </a:solidFill>
-                <a:latin typeface="Jua"/>
-                <a:ea typeface="Jua"/>
-                <a:cs typeface="Jua"/>
-                <a:sym typeface="Jua"/>
+                <a:latin typeface="무궁화 고딕"/>
+                <a:ea typeface="무궁화 고딕"/>
+                <a:cs typeface="무궁화 고딕"/>
+                <a:sym typeface="무궁화 고딕"/>
               </a:rPr>
               <a:t>Hint : 인터넷</a:t>
             </a:r>
@@ -13840,8 +13836,8 @@
         </p:nvSpPr>
         <p:spPr>
           <a:xfrm rot="0">
-            <a:off x="461635" y="3152775"/>
-            <a:ext cx="17364730" cy="3514725"/>
+            <a:off x="461635" y="3609975"/>
+            <a:ext cx="17364730" cy="3057525"/>
           </a:xfrm>
           <a:prstGeom prst="rect">
             <a:avLst/>
@@ -13863,10 +13859,10 @@
                 <a:solidFill>
                   <a:srgbClr val="000000"/>
                 </a:solidFill>
-                <a:latin typeface="Jua"/>
-                <a:ea typeface="Jua"/>
-                <a:cs typeface="Jua"/>
-                <a:sym typeface="Jua"/>
+                <a:latin typeface="무궁화 고딕"/>
+                <a:ea typeface="무궁화 고딕"/>
+                <a:cs typeface="무궁화 고딕"/>
+                <a:sym typeface="무궁화 고딕"/>
               </a:rPr>
               <a:t>컴퓨터</a:t>
             </a:r>
@@ -13963,8 +13959,8 @@
         </p:nvSpPr>
         <p:spPr>
           <a:xfrm rot="0">
-            <a:off x="461635" y="3152775"/>
-            <a:ext cx="17364730" cy="3514725"/>
+            <a:off x="461635" y="3609975"/>
+            <a:ext cx="17364730" cy="3057525"/>
           </a:xfrm>
           <a:prstGeom prst="rect">
             <a:avLst/>
@@ -13986,10 +13982,10 @@
                 <a:solidFill>
                   <a:srgbClr val="000000"/>
                 </a:solidFill>
-                <a:latin typeface="Jua"/>
-                <a:ea typeface="Jua"/>
-                <a:cs typeface="Jua"/>
-                <a:sym typeface="Jua"/>
+                <a:latin typeface="무궁화 고딕"/>
+                <a:ea typeface="무궁화 고딕"/>
+                <a:cs typeface="무궁화 고딕"/>
+                <a:sym typeface="무궁화 고딕"/>
               </a:rPr>
               <a:t>ㅋㄹㅅㅁㅅ</a:t>
             </a:r>
@@ -14086,8 +14082,8 @@
         </p:nvSpPr>
         <p:spPr>
           <a:xfrm rot="0">
-            <a:off x="461635" y="3152775"/>
-            <a:ext cx="17364730" cy="3514725"/>
+            <a:off x="461635" y="3609975"/>
+            <a:ext cx="17364730" cy="3057525"/>
           </a:xfrm>
           <a:prstGeom prst="rect">
             <a:avLst/>
@@ -14109,10 +14105,10 @@
                 <a:solidFill>
                   <a:srgbClr val="000000"/>
                 </a:solidFill>
-                <a:latin typeface="Jua"/>
-                <a:ea typeface="Jua"/>
-                <a:cs typeface="Jua"/>
-                <a:sym typeface="Jua"/>
+                <a:latin typeface="무궁화 고딕"/>
+                <a:ea typeface="무궁화 고딕"/>
+                <a:cs typeface="무궁화 고딕"/>
+                <a:sym typeface="무궁화 고딕"/>
               </a:rPr>
               <a:t>붕어빵</a:t>
             </a:r>
@@ -14209,8 +14205,8 @@
         </p:nvSpPr>
         <p:spPr>
           <a:xfrm rot="0">
-            <a:off x="461635" y="3152775"/>
-            <a:ext cx="17364730" cy="3514725"/>
+            <a:off x="461635" y="3609975"/>
+            <a:ext cx="17364730" cy="3057525"/>
           </a:xfrm>
           <a:prstGeom prst="rect">
             <a:avLst/>
@@ -14232,10 +14228,10 @@
                 <a:solidFill>
                   <a:srgbClr val="000000"/>
                 </a:solidFill>
-                <a:latin typeface="Jua"/>
-                <a:ea typeface="Jua"/>
-                <a:cs typeface="Jua"/>
-                <a:sym typeface="Jua"/>
+                <a:latin typeface="무궁화 고딕"/>
+                <a:ea typeface="무궁화 고딕"/>
+                <a:cs typeface="무궁화 고딕"/>
+                <a:sym typeface="무궁화 고딕"/>
               </a:rPr>
               <a:t>ㅋㄹㅅㅁㅅ</a:t>
             </a:r>
@@ -14250,8 +14246,8 @@
         </p:nvSpPr>
         <p:spPr>
           <a:xfrm rot="0">
-            <a:off x="461635" y="6533441"/>
-            <a:ext cx="17364730" cy="1952625"/>
+            <a:off x="461635" y="6800141"/>
+            <a:ext cx="17364730" cy="1685925"/>
           </a:xfrm>
           <a:prstGeom prst="rect">
             <a:avLst/>
@@ -14273,10 +14269,10 @@
                 <a:solidFill>
                   <a:srgbClr val="000000"/>
                 </a:solidFill>
-                <a:latin typeface="Jua"/>
-                <a:ea typeface="Jua"/>
-                <a:cs typeface="Jua"/>
-                <a:sym typeface="Jua"/>
+                <a:latin typeface="무궁화 고딕"/>
+                <a:ea typeface="무궁화 고딕"/>
+                <a:cs typeface="무궁화 고딕"/>
+                <a:sym typeface="무궁화 고딕"/>
               </a:rPr>
               <a:t>Hint : 예수님</a:t>
             </a:r>
@@ -14373,8 +14369,8 @@
         </p:nvSpPr>
         <p:spPr>
           <a:xfrm rot="0">
-            <a:off x="461635" y="3152775"/>
-            <a:ext cx="17364730" cy="3514725"/>
+            <a:off x="461635" y="3609975"/>
+            <a:ext cx="17364730" cy="3057525"/>
           </a:xfrm>
           <a:prstGeom prst="rect">
             <a:avLst/>
@@ -14396,10 +14392,10 @@
                 <a:solidFill>
                   <a:srgbClr val="000000"/>
                 </a:solidFill>
-                <a:latin typeface="Jua"/>
-                <a:ea typeface="Jua"/>
-                <a:cs typeface="Jua"/>
-                <a:sym typeface="Jua"/>
+                <a:latin typeface="무궁화 고딕"/>
+                <a:ea typeface="무궁화 고딕"/>
+                <a:cs typeface="무궁화 고딕"/>
+                <a:sym typeface="무궁화 고딕"/>
               </a:rPr>
               <a:t>크리스마스</a:t>
             </a:r>
@@ -14496,8 +14492,8 @@
         </p:nvSpPr>
         <p:spPr>
           <a:xfrm rot="0">
-            <a:off x="461635" y="3152775"/>
-            <a:ext cx="17364730" cy="3514725"/>
+            <a:off x="461635" y="3609975"/>
+            <a:ext cx="17364730" cy="3057525"/>
           </a:xfrm>
           <a:prstGeom prst="rect">
             <a:avLst/>
@@ -14519,10 +14515,10 @@
                 <a:solidFill>
                   <a:srgbClr val="000000"/>
                 </a:solidFill>
-                <a:latin typeface="Jua"/>
-                <a:ea typeface="Jua"/>
-                <a:cs typeface="Jua"/>
-                <a:sym typeface="Jua"/>
+                <a:latin typeface="무궁화 고딕"/>
+                <a:ea typeface="무궁화 고딕"/>
+                <a:cs typeface="무궁화 고딕"/>
+                <a:sym typeface="무궁화 고딕"/>
               </a:rPr>
               <a:t>ㅎㄷㅈㅎ</a:t>
             </a:r>
@@ -14619,8 +14615,8 @@
         </p:nvSpPr>
         <p:spPr>
           <a:xfrm rot="0">
-            <a:off x="461635" y="6785853"/>
-            <a:ext cx="17364730" cy="1514475"/>
+            <a:off x="461635" y="6985878"/>
+            <a:ext cx="17364730" cy="1314450"/>
           </a:xfrm>
           <a:prstGeom prst="rect">
             <a:avLst/>
@@ -14642,10 +14638,10 @@
                 <a:solidFill>
                   <a:srgbClr val="000000"/>
                 </a:solidFill>
-                <a:latin typeface="Jua"/>
-                <a:ea typeface="Jua"/>
-                <a:cs typeface="Jua"/>
-                <a:sym typeface="Jua"/>
+                <a:latin typeface="무궁화 고딕"/>
+                <a:ea typeface="무궁화 고딕"/>
+                <a:cs typeface="무궁화 고딕"/>
+                <a:sym typeface="무궁화 고딕"/>
               </a:rPr>
               <a:t>Hint : 전화도 하고 게임도 해요</a:t>
             </a:r>
@@ -14660,8 +14656,8 @@
         </p:nvSpPr>
         <p:spPr>
           <a:xfrm rot="0">
-            <a:off x="461635" y="3152775"/>
-            <a:ext cx="17364730" cy="3514725"/>
+            <a:off x="461635" y="3609975"/>
+            <a:ext cx="17364730" cy="3057525"/>
           </a:xfrm>
           <a:prstGeom prst="rect">
             <a:avLst/>
@@ -14683,10 +14679,10 @@
                 <a:solidFill>
                   <a:srgbClr val="000000"/>
                 </a:solidFill>
-                <a:latin typeface="Jua"/>
-                <a:ea typeface="Jua"/>
-                <a:cs typeface="Jua"/>
-                <a:sym typeface="Jua"/>
+                <a:latin typeface="무궁화 고딕"/>
+                <a:ea typeface="무궁화 고딕"/>
+                <a:cs typeface="무궁화 고딕"/>
+                <a:sym typeface="무궁화 고딕"/>
               </a:rPr>
               <a:t>ㅎㄷㅈㅎ</a:t>
             </a:r>
@@ -14783,8 +14779,8 @@
         </p:nvSpPr>
         <p:spPr>
           <a:xfrm rot="0">
-            <a:off x="461635" y="3152775"/>
-            <a:ext cx="17364730" cy="3514725"/>
+            <a:off x="461635" y="3609975"/>
+            <a:ext cx="17364730" cy="3057525"/>
           </a:xfrm>
           <a:prstGeom prst="rect">
             <a:avLst/>
@@ -14806,10 +14802,10 @@
                 <a:solidFill>
                   <a:srgbClr val="000000"/>
                 </a:solidFill>
-                <a:latin typeface="Jua"/>
-                <a:ea typeface="Jua"/>
-                <a:cs typeface="Jua"/>
-                <a:sym typeface="Jua"/>
+                <a:latin typeface="무궁화 고딕"/>
+                <a:ea typeface="무궁화 고딕"/>
+                <a:cs typeface="무궁화 고딕"/>
+                <a:sym typeface="무궁화 고딕"/>
               </a:rPr>
               <a:t>휴대전화</a:t>
             </a:r>
@@ -14881,8 +14877,8 @@
         </p:nvSpPr>
         <p:spPr>
           <a:xfrm rot="0">
-            <a:off x="4421807" y="3895725"/>
-            <a:ext cx="9444385" cy="2200275"/>
+            <a:off x="4421807" y="4181475"/>
+            <a:ext cx="9444385" cy="1914525"/>
           </a:xfrm>
           <a:prstGeom prst="rect">
             <a:avLst/>
@@ -14904,10 +14900,10 @@
                 <a:solidFill>
                   <a:srgbClr val="000000"/>
                 </a:solidFill>
-                <a:latin typeface="Jua"/>
-                <a:ea typeface="Jua"/>
-                <a:cs typeface="Jua"/>
-                <a:sym typeface="Jua"/>
+                <a:latin typeface="무궁화 고딕"/>
+                <a:ea typeface="무궁화 고딕"/>
+                <a:cs typeface="무궁화 고딕"/>
+                <a:sym typeface="무궁화 고딕"/>
               </a:rPr>
               <a:t>감사합니다!</a:t>
             </a:r>
@@ -15054,8 +15050,8 @@
         </p:nvSpPr>
         <p:spPr>
           <a:xfrm rot="0">
-            <a:off x="461635" y="3152775"/>
-            <a:ext cx="17364730" cy="3514725"/>
+            <a:off x="461635" y="3609975"/>
+            <a:ext cx="17364730" cy="3057525"/>
           </a:xfrm>
           <a:prstGeom prst="rect">
             <a:avLst/>
@@ -15077,10 +15073,10 @@
                 <a:solidFill>
                   <a:srgbClr val="000000"/>
                 </a:solidFill>
-                <a:latin typeface="Jua"/>
-                <a:ea typeface="Jua"/>
-                <a:cs typeface="Jua"/>
-                <a:sym typeface="Jua"/>
+                <a:latin typeface="무궁화 고딕"/>
+                <a:ea typeface="무궁화 고딕"/>
+                <a:cs typeface="무궁화 고딕"/>
+                <a:sym typeface="무궁화 고딕"/>
               </a:rPr>
               <a:t>ㄱㄱㅁ</a:t>
             </a:r>

</xml_diff>